<commit_message>
Update pitch deck to v3
- Prototype URL and team slide
- README: live demo link

Co-Authored-By: Claude Opus 5.5 <noreply@anthropic.com>
</commit_message>
<xml_diff>
--- a/docs/pitch/SportelloAmico_pitch.pptx
+++ b/docs/pitch/SportelloAmico_pitch.pptx
@@ -24,6 +24,7 @@
     <p:sldId id="269" r:id="rId18"/>
     <p:sldId id="270" r:id="rId19"/>
     <p:sldId id="271" r:id="rId20"/>
+    <p:sldId id="272" r:id="rId21"/>
   </p:sldIdLst>
   <p:sldSz cy="5143500" cx="9144000"/>
   <p:notesSz cx="5143500" cy="9144000"/>
@@ -258,7 +259,7 @@
   </p:defaultTextStyle>
   <p:extLst>
     <p:ext uri="GoogleSlidesCustomDataVersion2">
-      <go:slidesCustomData xmlns:go="http://customooxmlschemas.google.com/" r:id="rId21" roundtripDataSignature="AMtx7micnb35Hp3r0kqS+LZ1XCLEWQxknA=="/>
+      <go:slidesCustomData xmlns:go="http://customooxmlschemas.google.com/" r:id="rId22" roundtripDataSignature="AMtx7mhP1fkiUPmeJebtwksrK47FXoQ3dw=="/>
     </p:ext>
   </p:extLst>
 </p:presentation>
@@ -1834,7 +1835,7 @@
   <p:cSld>
     <p:spTree>
       <p:nvGrpSpPr>
-        <p:cNvPr id="127" name="Shape 127"/>
+        <p:cNvPr id="129" name="Shape 129"/>
         <p:cNvGrpSpPr/>
         <p:nvPr/>
       </p:nvGrpSpPr>
@@ -1848,7 +1849,7 @@
       </p:grpSpPr>
       <p:sp>
         <p:nvSpPr>
-          <p:cNvPr id="128" name="Google Shape;128;p8:notes"/>
+          <p:cNvPr id="130" name="Google Shape;130;p8:notes"/>
           <p:cNvSpPr/>
           <p:nvPr>
             <p:ph idx="2" type="sldImg"/>
@@ -1893,7 +1894,7 @@
       </p:sp>
       <p:sp>
         <p:nvSpPr>
-          <p:cNvPr id="129" name="Google Shape;129;p8:notes"/>
+          <p:cNvPr id="131" name="Google Shape;131;p8:notes"/>
           <p:cNvSpPr txBox="1"/>
           <p:nvPr>
             <p:ph idx="1" type="body"/>
@@ -1937,7 +1938,7 @@
       </p:sp>
       <p:sp>
         <p:nvSpPr>
-          <p:cNvPr id="130" name="Google Shape;130;p8:notes"/>
+          <p:cNvPr id="132" name="Google Shape;132;p8:notes"/>
           <p:cNvSpPr txBox="1"/>
           <p:nvPr>
             <p:ph idx="12" type="sldNum"/>
@@ -1992,7 +1993,7 @@
   <p:cSld>
     <p:spTree>
       <p:nvGrpSpPr>
-        <p:cNvPr id="156" name="Shape 156"/>
+        <p:cNvPr id="158" name="Shape 158"/>
         <p:cNvGrpSpPr/>
         <p:nvPr/>
       </p:nvGrpSpPr>
@@ -2006,7 +2007,7 @@
       </p:grpSpPr>
       <p:sp>
         <p:nvSpPr>
-          <p:cNvPr id="157" name="Google Shape;157;p9:notes"/>
+          <p:cNvPr id="159" name="Google Shape;159;p9:notes"/>
           <p:cNvSpPr/>
           <p:nvPr>
             <p:ph idx="2" type="sldImg"/>
@@ -2051,7 +2052,7 @@
       </p:sp>
       <p:sp>
         <p:nvSpPr>
-          <p:cNvPr id="158" name="Google Shape;158;p9:notes"/>
+          <p:cNvPr id="160" name="Google Shape;160;p9:notes"/>
           <p:cNvSpPr txBox="1"/>
           <p:nvPr>
             <p:ph idx="1" type="body"/>
@@ -2095,7 +2096,7 @@
       </p:sp>
       <p:sp>
         <p:nvSpPr>
-          <p:cNvPr id="159" name="Google Shape;159;p9:notes"/>
+          <p:cNvPr id="161" name="Google Shape;161;p9:notes"/>
           <p:cNvSpPr txBox="1"/>
           <p:nvPr>
             <p:ph idx="12" type="sldNum"/>
@@ -2150,7 +2151,7 @@
   <p:cSld>
     <p:spTree>
       <p:nvGrpSpPr>
-        <p:cNvPr id="194" name="Shape 194"/>
+        <p:cNvPr id="196" name="Shape 196"/>
         <p:cNvGrpSpPr/>
         <p:nvPr/>
       </p:nvGrpSpPr>
@@ -2164,7 +2165,7 @@
       </p:grpSpPr>
       <p:sp>
         <p:nvSpPr>
-          <p:cNvPr id="195" name="Google Shape;195;h1c30e251418f18d3_1_24:notes"/>
+          <p:cNvPr id="197" name="Google Shape;197;h1c30e251418f18d3_1_24:notes"/>
           <p:cNvSpPr/>
           <p:nvPr>
             <p:ph idx="2" type="sldImg"/>
@@ -2209,7 +2210,7 @@
       </p:sp>
       <p:sp>
         <p:nvSpPr>
-          <p:cNvPr id="196" name="Google Shape;196;h1c30e251418f18d3_1_24:notes"/>
+          <p:cNvPr id="198" name="Google Shape;198;h1c30e251418f18d3_1_24:notes"/>
           <p:cNvSpPr txBox="1"/>
           <p:nvPr>
             <p:ph idx="1" type="body"/>
@@ -2253,7 +2254,7 @@
       </p:sp>
       <p:sp>
         <p:nvSpPr>
-          <p:cNvPr id="197" name="Google Shape;197;h1c30e251418f18d3_1_24:notes"/>
+          <p:cNvPr id="199" name="Google Shape;199;h1c30e251418f18d3_1_24:notes"/>
           <p:cNvSpPr txBox="1"/>
           <p:nvPr>
             <p:ph idx="12" type="sldNum"/>
@@ -2308,7 +2309,7 @@
   <p:cSld>
     <p:spTree>
       <p:nvGrpSpPr>
-        <p:cNvPr id="201" name="Shape 201"/>
+        <p:cNvPr id="203" name="Shape 203"/>
         <p:cNvGrpSpPr/>
         <p:nvPr/>
       </p:nvGrpSpPr>
@@ -2322,7 +2323,7 @@
       </p:grpSpPr>
       <p:sp>
         <p:nvSpPr>
-          <p:cNvPr id="202" name="Google Shape;202;p10:notes"/>
+          <p:cNvPr id="204" name="Google Shape;204;p10:notes"/>
           <p:cNvSpPr/>
           <p:nvPr>
             <p:ph idx="2" type="sldImg"/>
@@ -2367,7 +2368,7 @@
       </p:sp>
       <p:sp>
         <p:nvSpPr>
-          <p:cNvPr id="203" name="Google Shape;203;p10:notes"/>
+          <p:cNvPr id="205" name="Google Shape;205;p10:notes"/>
           <p:cNvSpPr txBox="1"/>
           <p:nvPr>
             <p:ph idx="1" type="body"/>
@@ -2411,7 +2412,7 @@
       </p:sp>
       <p:sp>
         <p:nvSpPr>
-          <p:cNvPr id="204" name="Google Shape;204;p10:notes"/>
+          <p:cNvPr id="206" name="Google Shape;206;p10:notes"/>
           <p:cNvSpPr txBox="1"/>
           <p:nvPr>
             <p:ph idx="12" type="sldNum"/>
@@ -2466,7 +2467,7 @@
   <p:cSld>
     <p:spTree>
       <p:nvGrpSpPr>
-        <p:cNvPr id="240" name="Shape 240"/>
+        <p:cNvPr id="242" name="Shape 242"/>
         <p:cNvGrpSpPr/>
         <p:nvPr/>
       </p:nvGrpSpPr>
@@ -2480,7 +2481,7 @@
       </p:grpSpPr>
       <p:sp>
         <p:nvSpPr>
-          <p:cNvPr id="241" name="Google Shape;241;p11:notes"/>
+          <p:cNvPr id="243" name="Google Shape;243;p11:notes"/>
           <p:cNvSpPr/>
           <p:nvPr>
             <p:ph idx="2" type="sldImg"/>
@@ -2525,7 +2526,7 @@
       </p:sp>
       <p:sp>
         <p:nvSpPr>
-          <p:cNvPr id="242" name="Google Shape;242;p11:notes"/>
+          <p:cNvPr id="244" name="Google Shape;244;p11:notes"/>
           <p:cNvSpPr txBox="1"/>
           <p:nvPr>
             <p:ph idx="1" type="body"/>
@@ -2569,7 +2570,7 @@
       </p:sp>
       <p:sp>
         <p:nvSpPr>
-          <p:cNvPr id="243" name="Google Shape;243;p11:notes"/>
+          <p:cNvPr id="245" name="Google Shape;245;p11:notes"/>
           <p:cNvSpPr txBox="1"/>
           <p:nvPr>
             <p:ph idx="12" type="sldNum"/>
@@ -2624,7 +2625,7 @@
   <p:cSld>
     <p:spTree>
       <p:nvGrpSpPr>
-        <p:cNvPr id="265" name="Shape 265"/>
+        <p:cNvPr id="267" name="Shape 267"/>
         <p:cNvGrpSpPr/>
         <p:nvPr/>
       </p:nvGrpSpPr>
@@ -2638,7 +2639,7 @@
       </p:grpSpPr>
       <p:sp>
         <p:nvSpPr>
-          <p:cNvPr id="266" name="Google Shape;266;p12:notes"/>
+          <p:cNvPr id="268" name="Google Shape;268;p12:notes"/>
           <p:cNvSpPr/>
           <p:nvPr>
             <p:ph idx="2" type="sldImg"/>
@@ -2683,7 +2684,7 @@
       </p:sp>
       <p:sp>
         <p:nvSpPr>
-          <p:cNvPr id="267" name="Google Shape;267;p12:notes"/>
+          <p:cNvPr id="269" name="Google Shape;269;p12:notes"/>
           <p:cNvSpPr txBox="1"/>
           <p:nvPr>
             <p:ph idx="1" type="body"/>
@@ -2727,7 +2728,7 @@
       </p:sp>
       <p:sp>
         <p:nvSpPr>
-          <p:cNvPr id="268" name="Google Shape;268;p12:notes"/>
+          <p:cNvPr id="270" name="Google Shape;270;p12:notes"/>
           <p:cNvSpPr txBox="1"/>
           <p:nvPr>
             <p:ph idx="12" type="sldNum"/>
@@ -2782,7 +2783,7 @@
   <p:cSld>
     <p:spTree>
       <p:nvGrpSpPr>
-        <p:cNvPr id="286" name="Shape 286"/>
+        <p:cNvPr id="288" name="Shape 288"/>
         <p:cNvGrpSpPr/>
         <p:nvPr/>
       </p:nvGrpSpPr>
@@ -2796,7 +2797,7 @@
       </p:grpSpPr>
       <p:sp>
         <p:nvSpPr>
-          <p:cNvPr id="287" name="Google Shape;287;p13:notes"/>
+          <p:cNvPr id="289" name="Google Shape;289;p13:notes"/>
           <p:cNvSpPr/>
           <p:nvPr>
             <p:ph idx="2" type="sldImg"/>
@@ -2841,7 +2842,7 @@
       </p:sp>
       <p:sp>
         <p:nvSpPr>
-          <p:cNvPr id="288" name="Google Shape;288;p13:notes"/>
+          <p:cNvPr id="290" name="Google Shape;290;p13:notes"/>
           <p:cNvSpPr txBox="1"/>
           <p:nvPr>
             <p:ph idx="1" type="body"/>
@@ -2885,7 +2886,7 @@
       </p:sp>
       <p:sp>
         <p:nvSpPr>
-          <p:cNvPr id="289" name="Google Shape;289;p13:notes"/>
+          <p:cNvPr id="291" name="Google Shape;291;p13:notes"/>
           <p:cNvSpPr txBox="1"/>
           <p:nvPr>
             <p:ph idx="12" type="sldNum"/>
@@ -2935,12 +2936,12 @@
 </p:notes>
 </file>
 
-<file path=ppt/notesSlides/notesSlide2.xml><?xml version="1.0" encoding="utf-8"?>
+<file path=ppt/notesSlides/notesSlide17.xml><?xml version="1.0" encoding="utf-8"?>
 <p:notes xmlns:a="http://schemas.openxmlformats.org/drawingml/2006/main" xmlns:r="http://schemas.openxmlformats.org/officeDocument/2006/relationships" xmlns:mc="http://schemas.openxmlformats.org/markup-compatibility/2006" xmlns:mv="urn:schemas-microsoft-com:mac:vml" xmlns:p="http://schemas.openxmlformats.org/presentationml/2006/main" xmlns:c="http://schemas.openxmlformats.org/drawingml/2006/chart" xmlns:dgm="http://schemas.openxmlformats.org/drawingml/2006/diagram" xmlns:o="urn:schemas-microsoft-com:office:office" xmlns:v="urn:schemas-microsoft-com:vml" xmlns:pvml="urn:schemas-microsoft-com:office:powerpoint" xmlns:com="http://schemas.openxmlformats.org/drawingml/2006/compatibility" xmlns:p14="http://schemas.microsoft.com/office/powerpoint/2010/main" xmlns:p15="http://schemas.microsoft.com/office/powerpoint/2012/main" xmlns:ahyp="http://schemas.microsoft.com/office/drawing/2018/hyperlinkcolor" showMasterPhAnim="0" showMasterSp="0">
   <p:cSld>
     <p:spTree>
       <p:nvGrpSpPr>
-        <p:cNvPr id="22" name="Shape 22"/>
+        <p:cNvPr id="309" name="Shape 309"/>
         <p:cNvGrpSpPr/>
         <p:nvPr/>
       </p:nvGrpSpPr>
@@ -2954,7 +2955,7 @@
       </p:grpSpPr>
       <p:sp>
         <p:nvSpPr>
-          <p:cNvPr id="23" name="Google Shape;23;p2:notes"/>
+          <p:cNvPr id="310" name="Google Shape;310;h1c30e251418f18d3_5_0:notes"/>
           <p:cNvSpPr/>
           <p:nvPr>
             <p:ph idx="2" type="sldImg"/>
@@ -2999,7 +3000,7 @@
       </p:sp>
       <p:sp>
         <p:nvSpPr>
-          <p:cNvPr id="24" name="Google Shape;24;p2:notes"/>
+          <p:cNvPr id="311" name="Google Shape;311;h1c30e251418f18d3_5_0:notes"/>
           <p:cNvSpPr txBox="1"/>
           <p:nvPr>
             <p:ph idx="1" type="body"/>
@@ -3008,7 +3009,7 @@
         <p:spPr>
           <a:xfrm>
             <a:off x="685800" y="4400550"/>
-            <a:ext cx="5486400" cy="3600450"/>
+            <a:ext cx="5486400" cy="3600600"/>
           </a:xfrm>
           <a:prstGeom prst="rect">
             <a:avLst/>
@@ -3035,7 +3036,7 @@
             </a:pPr>
             <a:r>
               <a:rPr lang="en-US"/>
-              <a:t>Dieci schermate, cinque enti diversi da capire, un mese di attesa e un solo ufficio in tutta la città. E chi lo chiede spesso ha ottant'anni, oppure è una figlia che lo fa per la madre.</a:t>
+              <a:t>Non serve rifare il modulo. Oggi il prototipo usa i dati aperti e il modulo esistente. Nel pilota basta un link dalla pagina del servizio e lo SPID che il Comune usa già; la scheda dei controlli può accompagnare la pratica. Poi si scala ad altre procedure e allo stato della pratica, con valutazione d'impatto privacy. Chiediamo un test con venti cittadini e con l'ufficio pass, per misurare tempi ed errori con e senza assistente. Grazie.</a:t>
             </a:r>
             <a:endParaRPr/>
           </a:p>
@@ -3043,7 +3044,7 @@
       </p:sp>
       <p:sp>
         <p:nvSpPr>
-          <p:cNvPr id="25" name="Google Shape;25;p2:notes"/>
+          <p:cNvPr id="312" name="Google Shape;312;h1c30e251418f18d3_5_0:notes"/>
           <p:cNvSpPr txBox="1"/>
           <p:nvPr>
             <p:ph idx="12" type="sldNum"/>
@@ -3052,7 +3053,7 @@
         <p:spPr>
           <a:xfrm>
             <a:off x="3884613" y="8685213"/>
-            <a:ext cx="2971800" cy="458787"/>
+            <a:ext cx="2971800" cy="458700"/>
           </a:xfrm>
           <a:prstGeom prst="rect">
             <a:avLst/>
@@ -3093,12 +3094,12 @@
 </p:notes>
 </file>
 
-<file path=ppt/notesSlides/notesSlide3.xml><?xml version="1.0" encoding="utf-8"?>
+<file path=ppt/notesSlides/notesSlide2.xml><?xml version="1.0" encoding="utf-8"?>
 <p:notes xmlns:a="http://schemas.openxmlformats.org/drawingml/2006/main" xmlns:r="http://schemas.openxmlformats.org/officeDocument/2006/relationships" xmlns:mc="http://schemas.openxmlformats.org/markup-compatibility/2006" xmlns:mv="urn:schemas-microsoft-com:mac:vml" xmlns:p="http://schemas.openxmlformats.org/presentationml/2006/main" xmlns:c="http://schemas.openxmlformats.org/drawingml/2006/chart" xmlns:dgm="http://schemas.openxmlformats.org/drawingml/2006/diagram" xmlns:o="urn:schemas-microsoft-com:office:office" xmlns:v="urn:schemas-microsoft-com:vml" xmlns:pvml="urn:schemas-microsoft-com:office:powerpoint" xmlns:com="http://schemas.openxmlformats.org/drawingml/2006/compatibility" xmlns:p14="http://schemas.microsoft.com/office/powerpoint/2010/main" xmlns:p15="http://schemas.microsoft.com/office/powerpoint/2012/main" xmlns:ahyp="http://schemas.microsoft.com/office/drawing/2018/hyperlinkcolor" showMasterPhAnim="0" showMasterSp="0">
   <p:cSld>
     <p:spTree>
       <p:nvGrpSpPr>
-        <p:cNvPr id="41" name="Shape 41"/>
+        <p:cNvPr id="24" name="Shape 24"/>
         <p:cNvGrpSpPr/>
         <p:nvPr/>
       </p:nvGrpSpPr>
@@ -3112,7 +3113,7 @@
       </p:grpSpPr>
       <p:sp>
         <p:nvSpPr>
-          <p:cNvPr id="42" name="Google Shape;42;p3:notes"/>
+          <p:cNvPr id="25" name="Google Shape;25;p2:notes"/>
           <p:cNvSpPr/>
           <p:nvPr>
             <p:ph idx="2" type="sldImg"/>
@@ -3157,7 +3158,7 @@
       </p:sp>
       <p:sp>
         <p:nvSpPr>
-          <p:cNvPr id="43" name="Google Shape;43;p3:notes"/>
+          <p:cNvPr id="26" name="Google Shape;26;p2:notes"/>
           <p:cNvSpPr txBox="1"/>
           <p:nvPr>
             <p:ph idx="1" type="body"/>
@@ -3193,7 +3194,7 @@
             </a:pPr>
             <a:r>
               <a:rPr lang="en-US"/>
-              <a:t>Questo è l'esempio di verbale che il Comune pubblica nel modulo: è solo la pagina cinque di sette. È proprio l'errore più facile da fare, e uno dei motivi per cui le domande tornano indietro incomplete. Le altre regole nascoste: la frase esatta del medico per il rinnovo, le foto dell'iPhone in formato HEIC rifiutate, la scelta della consegna che non si può cambiare, la targa con la piattaforma nazionale.</a:t>
+              <a:t>Dieci schermate, cinque enti diversi da capire, un mese di attesa e un solo ufficio in tutta la città. E chi lo chiede spesso ha ottant'anni, oppure è una figlia che lo fa per la madre.</a:t>
             </a:r>
             <a:endParaRPr/>
           </a:p>
@@ -3201,7 +3202,7 @@
       </p:sp>
       <p:sp>
         <p:nvSpPr>
-          <p:cNvPr id="44" name="Google Shape;44;p3:notes"/>
+          <p:cNvPr id="27" name="Google Shape;27;p2:notes"/>
           <p:cNvSpPr txBox="1"/>
           <p:nvPr>
             <p:ph idx="12" type="sldNum"/>
@@ -3251,12 +3252,12 @@
 </p:notes>
 </file>
 
-<file path=ppt/notesSlides/notesSlide4.xml><?xml version="1.0" encoding="utf-8"?>
+<file path=ppt/notesSlides/notesSlide3.xml><?xml version="1.0" encoding="utf-8"?>
 <p:notes xmlns:a="http://schemas.openxmlformats.org/drawingml/2006/main" xmlns:r="http://schemas.openxmlformats.org/officeDocument/2006/relationships" xmlns:mc="http://schemas.openxmlformats.org/markup-compatibility/2006" xmlns:mv="urn:schemas-microsoft-com:mac:vml" xmlns:p="http://schemas.openxmlformats.org/presentationml/2006/main" xmlns:c="http://schemas.openxmlformats.org/drawingml/2006/chart" xmlns:dgm="http://schemas.openxmlformats.org/drawingml/2006/diagram" xmlns:o="urn:schemas-microsoft-com:office:office" xmlns:v="urn:schemas-microsoft-com:vml" xmlns:pvml="urn:schemas-microsoft-com:office:powerpoint" xmlns:com="http://schemas.openxmlformats.org/drawingml/2006/compatibility" xmlns:p14="http://schemas.microsoft.com/office/powerpoint/2010/main" xmlns:p15="http://schemas.microsoft.com/office/powerpoint/2012/main" xmlns:ahyp="http://schemas.microsoft.com/office/drawing/2018/hyperlinkcolor" showMasterPhAnim="0" showMasterSp="0">
   <p:cSld>
     <p:spTree>
       <p:nvGrpSpPr>
-        <p:cNvPr id="51" name="Shape 51"/>
+        <p:cNvPr id="43" name="Shape 43"/>
         <p:cNvGrpSpPr/>
         <p:nvPr/>
       </p:nvGrpSpPr>
@@ -3270,7 +3271,7 @@
       </p:grpSpPr>
       <p:sp>
         <p:nvSpPr>
-          <p:cNvPr id="52" name="Google Shape;52;p4:notes"/>
+          <p:cNvPr id="44" name="Google Shape;44;p3:notes"/>
           <p:cNvSpPr/>
           <p:nvPr>
             <p:ph idx="2" type="sldImg"/>
@@ -3315,7 +3316,7 @@
       </p:sp>
       <p:sp>
         <p:nvSpPr>
-          <p:cNvPr id="53" name="Google Shape;53;p4:notes"/>
+          <p:cNvPr id="45" name="Google Shape;45;p3:notes"/>
           <p:cNvSpPr txBox="1"/>
           <p:nvPr>
             <p:ph idx="1" type="body"/>
@@ -3351,7 +3352,7 @@
             </a:pPr>
             <a:r>
               <a:rPr lang="en-US"/>
-              <a:t>Non è un'impressione. Il Comune pubblica i questionari di soddisfazione: sul servizio gemello, il pass sosta residenti, oltre ottomila risposte nel 2024. Le difficoltà più citate sono la complessità della procedura e la ricerca delle informazioni. E per la residenza online di chi arriva dall'estero, la facilità media è tre virgola due su cinque.</a:t>
+              <a:t>Questo è l'esempio di verbale che il Comune pubblica nel modulo: è solo la pagina cinque di sette. È proprio l'errore più facile da fare, e uno dei motivi per cui le domande tornano indietro incomplete. Le altre regole nascoste: la frase esatta del medico per il rinnovo, le foto dell'iPhone in formato HEIC rifiutate, la scelta della consegna che non si può cambiare, la targa con la piattaforma nazionale.</a:t>
             </a:r>
             <a:endParaRPr/>
           </a:p>
@@ -3359,7 +3360,7 @@
       </p:sp>
       <p:sp>
         <p:nvSpPr>
-          <p:cNvPr id="54" name="Google Shape;54;p4:notes"/>
+          <p:cNvPr id="46" name="Google Shape;46;p3:notes"/>
           <p:cNvSpPr txBox="1"/>
           <p:nvPr>
             <p:ph idx="12" type="sldNum"/>
@@ -3409,12 +3410,12 @@
 </p:notes>
 </file>
 
-<file path=ppt/notesSlides/notesSlide5.xml><?xml version="1.0" encoding="utf-8"?>
+<file path=ppt/notesSlides/notesSlide4.xml><?xml version="1.0" encoding="utf-8"?>
 <p:notes xmlns:a="http://schemas.openxmlformats.org/drawingml/2006/main" xmlns:r="http://schemas.openxmlformats.org/officeDocument/2006/relationships" xmlns:mc="http://schemas.openxmlformats.org/markup-compatibility/2006" xmlns:mv="urn:schemas-microsoft-com:mac:vml" xmlns:p="http://schemas.openxmlformats.org/presentationml/2006/main" xmlns:c="http://schemas.openxmlformats.org/drawingml/2006/chart" xmlns:dgm="http://schemas.openxmlformats.org/drawingml/2006/diagram" xmlns:o="urn:schemas-microsoft-com:office:office" xmlns:v="urn:schemas-microsoft-com:vml" xmlns:pvml="urn:schemas-microsoft-com:office:powerpoint" xmlns:com="http://schemas.openxmlformats.org/drawingml/2006/compatibility" xmlns:p14="http://schemas.microsoft.com/office/powerpoint/2010/main" xmlns:p15="http://schemas.microsoft.com/office/powerpoint/2012/main" xmlns:ahyp="http://schemas.microsoft.com/office/drawing/2018/hyperlinkcolor" showMasterPhAnim="0" showMasterSp="0">
   <p:cSld>
     <p:spTree>
       <p:nvGrpSpPr>
-        <p:cNvPr id="64" name="Shape 64"/>
+        <p:cNvPr id="53" name="Shape 53"/>
         <p:cNvGrpSpPr/>
         <p:nvPr/>
       </p:nvGrpSpPr>
@@ -3428,7 +3429,7 @@
       </p:grpSpPr>
       <p:sp>
         <p:nvSpPr>
-          <p:cNvPr id="65" name="Google Shape;65;p5:notes"/>
+          <p:cNvPr id="54" name="Google Shape;54;p4:notes"/>
           <p:cNvSpPr/>
           <p:nvPr>
             <p:ph idx="2" type="sldImg"/>
@@ -3473,7 +3474,7 @@
       </p:sp>
       <p:sp>
         <p:nvSpPr>
-          <p:cNvPr id="66" name="Google Shape;66;p5:notes"/>
+          <p:cNvPr id="55" name="Google Shape;55;p4:notes"/>
           <p:cNvSpPr txBox="1"/>
           <p:nvPr>
             <p:ph idx="1" type="body"/>
@@ -3509,7 +3510,7 @@
             </a:pPr>
             <a:r>
               <a:rPr lang="en-US"/>
-              <a:t>La soluzione usa una metafora che tutti conoscono: uno sportello e una busta. Tre domande, poi i documenti entrano nella busta uno alla volta. Claude legge il documento sanitario e ci mette un timbro: va bene, mancano pagine, manca la frase del medico. In più prepara la delega da firmare e la lettera per il medico.</a:t>
+              <a:t>Non è un'impressione. Il Comune pubblica i questionari di soddisfazione: sul servizio gemello, il pass sosta residenti, oltre ottomila risposte nel 2024. Le difficoltà più citate sono la complessità della procedura e la ricerca delle informazioni. E per la residenza online di chi arriva dall'estero, la facilità media è tre virgola due su cinque.</a:t>
             </a:r>
             <a:endParaRPr/>
           </a:p>
@@ -3517,7 +3518,7 @@
       </p:sp>
       <p:sp>
         <p:nvSpPr>
-          <p:cNvPr id="67" name="Google Shape;67;p5:notes"/>
+          <p:cNvPr id="56" name="Google Shape;56;p4:notes"/>
           <p:cNvSpPr txBox="1"/>
           <p:nvPr>
             <p:ph idx="12" type="sldNum"/>
@@ -3567,12 +3568,12 @@
 </p:notes>
 </file>
 
-<file path=ppt/notesSlides/notesSlide6.xml><?xml version="1.0" encoding="utf-8"?>
+<file path=ppt/notesSlides/notesSlide5.xml><?xml version="1.0" encoding="utf-8"?>
 <p:notes xmlns:a="http://schemas.openxmlformats.org/drawingml/2006/main" xmlns:r="http://schemas.openxmlformats.org/officeDocument/2006/relationships" xmlns:mc="http://schemas.openxmlformats.org/markup-compatibility/2006" xmlns:mv="urn:schemas-microsoft-com:mac:vml" xmlns:p="http://schemas.openxmlformats.org/presentationml/2006/main" xmlns:c="http://schemas.openxmlformats.org/drawingml/2006/chart" xmlns:dgm="http://schemas.openxmlformats.org/drawingml/2006/diagram" xmlns:o="urn:schemas-microsoft-com:office:office" xmlns:v="urn:schemas-microsoft-com:vml" xmlns:pvml="urn:schemas-microsoft-com:office:powerpoint" xmlns:com="http://schemas.openxmlformats.org/drawingml/2006/compatibility" xmlns:p14="http://schemas.microsoft.com/office/powerpoint/2010/main" xmlns:p15="http://schemas.microsoft.com/office/powerpoint/2012/main" xmlns:ahyp="http://schemas.microsoft.com/office/drawing/2018/hyperlinkcolor" showMasterPhAnim="0" showMasterSp="0">
   <p:cSld>
     <p:spTree>
       <p:nvGrpSpPr>
-        <p:cNvPr id="78" name="Shape 78"/>
+        <p:cNvPr id="66" name="Shape 66"/>
         <p:cNvGrpSpPr/>
         <p:nvPr/>
       </p:nvGrpSpPr>
@@ -3586,7 +3587,7 @@
       </p:grpSpPr>
       <p:sp>
         <p:nvSpPr>
-          <p:cNvPr id="79" name="Google Shape;79;h1c30e251418f18d3_1_10:notes"/>
+          <p:cNvPr id="67" name="Google Shape;67;p5:notes"/>
           <p:cNvSpPr/>
           <p:nvPr>
             <p:ph idx="2" type="sldImg"/>
@@ -3631,7 +3632,7 @@
       </p:sp>
       <p:sp>
         <p:nvSpPr>
-          <p:cNvPr id="80" name="Google Shape;80;h1c30e251418f18d3_1_10:notes"/>
+          <p:cNvPr id="68" name="Google Shape;68;p5:notes"/>
           <p:cNvSpPr txBox="1"/>
           <p:nvPr>
             <p:ph idx="1" type="body"/>
@@ -3640,7 +3641,7 @@
         <p:spPr>
           <a:xfrm>
             <a:off x="685800" y="4400550"/>
-            <a:ext cx="5486400" cy="3600600"/>
+            <a:ext cx="5486400" cy="3600450"/>
           </a:xfrm>
           <a:prstGeom prst="rect">
             <a:avLst/>
@@ -3675,7 +3676,7 @@
       </p:sp>
       <p:sp>
         <p:nvSpPr>
-          <p:cNvPr id="81" name="Google Shape;81;h1c30e251418f18d3_1_10:notes"/>
+          <p:cNvPr id="69" name="Google Shape;69;p5:notes"/>
           <p:cNvSpPr txBox="1"/>
           <p:nvPr>
             <p:ph idx="12" type="sldNum"/>
@@ -3684,7 +3685,7 @@
         <p:spPr>
           <a:xfrm>
             <a:off x="3884613" y="8685213"/>
-            <a:ext cx="2971800" cy="458700"/>
+            <a:ext cx="2971800" cy="458787"/>
           </a:xfrm>
           <a:prstGeom prst="rect">
             <a:avLst/>
@@ -3725,12 +3726,12 @@
 </p:notes>
 </file>
 
-<file path=ppt/notesSlides/notesSlide7.xml><?xml version="1.0" encoding="utf-8"?>
+<file path=ppt/notesSlides/notesSlide6.xml><?xml version="1.0" encoding="utf-8"?>
 <p:notes xmlns:a="http://schemas.openxmlformats.org/drawingml/2006/main" xmlns:r="http://schemas.openxmlformats.org/officeDocument/2006/relationships" xmlns:mc="http://schemas.openxmlformats.org/markup-compatibility/2006" xmlns:mv="urn:schemas-microsoft-com:mac:vml" xmlns:p="http://schemas.openxmlformats.org/presentationml/2006/main" xmlns:c="http://schemas.openxmlformats.org/drawingml/2006/chart" xmlns:dgm="http://schemas.openxmlformats.org/drawingml/2006/diagram" xmlns:o="urn:schemas-microsoft-com:office:office" xmlns:v="urn:schemas-microsoft-com:vml" xmlns:pvml="urn:schemas-microsoft-com:office:powerpoint" xmlns:com="http://schemas.openxmlformats.org/drawingml/2006/compatibility" xmlns:p14="http://schemas.microsoft.com/office/powerpoint/2010/main" xmlns:p15="http://schemas.microsoft.com/office/powerpoint/2012/main" xmlns:ahyp="http://schemas.microsoft.com/office/drawing/2018/hyperlinkcolor" showMasterPhAnim="0" showMasterSp="0">
   <p:cSld>
     <p:spTree>
       <p:nvGrpSpPr>
-        <p:cNvPr id="85" name="Shape 85"/>
+        <p:cNvPr id="80" name="Shape 80"/>
         <p:cNvGrpSpPr/>
         <p:nvPr/>
       </p:nvGrpSpPr>
@@ -3744,7 +3745,7 @@
       </p:grpSpPr>
       <p:sp>
         <p:nvSpPr>
-          <p:cNvPr id="86" name="Google Shape;86;h1c30e251418f18d3_2_2:notes"/>
+          <p:cNvPr id="81" name="Google Shape;81;h1c30e251418f18d3_1_10:notes"/>
           <p:cNvSpPr/>
           <p:nvPr>
             <p:ph idx="2" type="sldImg"/>
@@ -3789,7 +3790,7 @@
       </p:sp>
       <p:sp>
         <p:nvSpPr>
-          <p:cNvPr id="87" name="Google Shape;87;h1c30e251418f18d3_2_2:notes"/>
+          <p:cNvPr id="82" name="Google Shape;82;h1c30e251418f18d3_1_10:notes"/>
           <p:cNvSpPr txBox="1"/>
           <p:nvPr>
             <p:ph idx="1" type="body"/>
@@ -3833,7 +3834,7 @@
       </p:sp>
       <p:sp>
         <p:nvSpPr>
-          <p:cNvPr id="88" name="Google Shape;88;h1c30e251418f18d3_2_2:notes"/>
+          <p:cNvPr id="83" name="Google Shape;83;h1c30e251418f18d3_1_10:notes"/>
           <p:cNvSpPr txBox="1"/>
           <p:nvPr>
             <p:ph idx="12" type="sldNum"/>
@@ -3883,12 +3884,12 @@
 </p:notes>
 </file>
 
-<file path=ppt/notesSlides/notesSlide8.xml><?xml version="1.0" encoding="utf-8"?>
+<file path=ppt/notesSlides/notesSlide7.xml><?xml version="1.0" encoding="utf-8"?>
 <p:notes xmlns:a="http://schemas.openxmlformats.org/drawingml/2006/main" xmlns:r="http://schemas.openxmlformats.org/officeDocument/2006/relationships" xmlns:mc="http://schemas.openxmlformats.org/markup-compatibility/2006" xmlns:mv="urn:schemas-microsoft-com:mac:vml" xmlns:p="http://schemas.openxmlformats.org/presentationml/2006/main" xmlns:c="http://schemas.openxmlformats.org/drawingml/2006/chart" xmlns:dgm="http://schemas.openxmlformats.org/drawingml/2006/diagram" xmlns:o="urn:schemas-microsoft-com:office:office" xmlns:v="urn:schemas-microsoft-com:vml" xmlns:pvml="urn:schemas-microsoft-com:office:powerpoint" xmlns:com="http://schemas.openxmlformats.org/drawingml/2006/compatibility" xmlns:p14="http://schemas.microsoft.com/office/powerpoint/2010/main" xmlns:p15="http://schemas.microsoft.com/office/powerpoint/2012/main" xmlns:ahyp="http://schemas.microsoft.com/office/drawing/2018/hyperlinkcolor" showMasterPhAnim="0" showMasterSp="0">
   <p:cSld>
     <p:spTree>
       <p:nvGrpSpPr>
-        <p:cNvPr id="92" name="Shape 92"/>
+        <p:cNvPr id="87" name="Shape 87"/>
         <p:cNvGrpSpPr/>
         <p:nvPr/>
       </p:nvGrpSpPr>
@@ -3902,7 +3903,7 @@
       </p:grpSpPr>
       <p:sp>
         <p:nvSpPr>
-          <p:cNvPr id="93" name="Google Shape;93;p6:notes"/>
+          <p:cNvPr id="88" name="Google Shape;88;h1c30e251418f18d3_2_2:notes"/>
           <p:cNvSpPr/>
           <p:nvPr>
             <p:ph idx="2" type="sldImg"/>
@@ -3947,7 +3948,7 @@
       </p:sp>
       <p:sp>
         <p:nvSpPr>
-          <p:cNvPr id="94" name="Google Shape;94;p6:notes"/>
+          <p:cNvPr id="89" name="Google Shape;89;h1c30e251418f18d3_2_2:notes"/>
           <p:cNvSpPr txBox="1"/>
           <p:nvPr>
             <p:ph idx="1" type="body"/>
@@ -3956,7 +3957,7 @@
         <p:spPr>
           <a:xfrm>
             <a:off x="685800" y="4400550"/>
-            <a:ext cx="5486400" cy="3600450"/>
+            <a:ext cx="5486400" cy="3600600"/>
           </a:xfrm>
           <a:prstGeom prst="rect">
             <a:avLst/>
@@ -3983,7 +3984,7 @@
             </a:pPr>
             <a:r>
               <a:rPr lang="en-US"/>
-              <a:t>Poi l'assistente mostra la replica di ogni schermata del modulo vero del Comune, con il punto da toccare evidenziato e la scelta giusta per quella persona. Prima di premere invia facciamo la prova generale: Claude guarda lo screenshot del riepilogo e trova i problemi, qui tre, quando si possono ancora correggere.</a:t>
+              <a:t>La soluzione usa una metafora che tutti conoscono: uno sportello e una busta. Tre domande, poi i documenti entrano nella busta uno alla volta. Claude legge il documento sanitario e ci mette un timbro: va bene, mancano pagine, manca la frase del medico. In più prepara la delega da firmare e la lettera per il medico.</a:t>
             </a:r>
             <a:endParaRPr/>
           </a:p>
@@ -3991,7 +3992,7 @@
       </p:sp>
       <p:sp>
         <p:nvSpPr>
-          <p:cNvPr id="95" name="Google Shape;95;p6:notes"/>
+          <p:cNvPr id="90" name="Google Shape;90;h1c30e251418f18d3_2_2:notes"/>
           <p:cNvSpPr txBox="1"/>
           <p:nvPr>
             <p:ph idx="12" type="sldNum"/>
@@ -4000,7 +4001,7 @@
         <p:spPr>
           <a:xfrm>
             <a:off x="3884613" y="8685213"/>
-            <a:ext cx="2971800" cy="458787"/>
+            <a:ext cx="2971800" cy="458700"/>
           </a:xfrm>
           <a:prstGeom prst="rect">
             <a:avLst/>
@@ -4041,12 +4042,12 @@
 </p:notes>
 </file>
 
-<file path=ppt/notesSlides/notesSlide9.xml><?xml version="1.0" encoding="utf-8"?>
+<file path=ppt/notesSlides/notesSlide8.xml><?xml version="1.0" encoding="utf-8"?>
 <p:notes xmlns:a="http://schemas.openxmlformats.org/drawingml/2006/main" xmlns:r="http://schemas.openxmlformats.org/officeDocument/2006/relationships" xmlns:mc="http://schemas.openxmlformats.org/markup-compatibility/2006" xmlns:mv="urn:schemas-microsoft-com:mac:vml" xmlns:p="http://schemas.openxmlformats.org/presentationml/2006/main" xmlns:c="http://schemas.openxmlformats.org/drawingml/2006/chart" xmlns:dgm="http://schemas.openxmlformats.org/drawingml/2006/diagram" xmlns:o="urn:schemas-microsoft-com:office:office" xmlns:v="urn:schemas-microsoft-com:vml" xmlns:pvml="urn:schemas-microsoft-com:office:powerpoint" xmlns:com="http://schemas.openxmlformats.org/drawingml/2006/compatibility" xmlns:p14="http://schemas.microsoft.com/office/powerpoint/2010/main" xmlns:p15="http://schemas.microsoft.com/office/powerpoint/2012/main" xmlns:ahyp="http://schemas.microsoft.com/office/drawing/2018/hyperlinkcolor" showMasterPhAnim="0" showMasterSp="0">
   <p:cSld>
     <p:spTree>
       <p:nvGrpSpPr>
-        <p:cNvPr id="103" name="Shape 103"/>
+        <p:cNvPr id="94" name="Shape 94"/>
         <p:cNvGrpSpPr/>
         <p:nvPr/>
       </p:nvGrpSpPr>
@@ -4060,7 +4061,7 @@
       </p:grpSpPr>
       <p:sp>
         <p:nvSpPr>
-          <p:cNvPr id="104" name="Google Shape;104;p7:notes"/>
+          <p:cNvPr id="95" name="Google Shape;95;p6:notes"/>
           <p:cNvSpPr/>
           <p:nvPr>
             <p:ph idx="2" type="sldImg"/>
@@ -4105,7 +4106,7 @@
       </p:sp>
       <p:sp>
         <p:nvSpPr>
-          <p:cNvPr id="105" name="Google Shape;105;p7:notes"/>
+          <p:cNvPr id="96" name="Google Shape;96;p6:notes"/>
           <p:cNvSpPr txBox="1"/>
           <p:nvPr>
             <p:ph idx="1" type="body"/>
@@ -4141,6 +4142,164 @@
             </a:pPr>
             <a:r>
               <a:rPr lang="en-US"/>
+              <a:t>Poi l'assistente mostra la replica di ogni schermata del modulo vero del Comune, con il punto da toccare evidenziato e la scelta giusta per quella persona. Prima di premere invia facciamo la prova generale: Claude guarda lo screenshot del riepilogo e trova i problemi, qui tre, quando si possono ancora correggere.</a:t>
+            </a:r>
+            <a:endParaRPr/>
+          </a:p>
+        </p:txBody>
+      </p:sp>
+      <p:sp>
+        <p:nvSpPr>
+          <p:cNvPr id="97" name="Google Shape;97;p6:notes"/>
+          <p:cNvSpPr txBox="1"/>
+          <p:nvPr>
+            <p:ph idx="12" type="sldNum"/>
+          </p:nvPr>
+        </p:nvSpPr>
+        <p:spPr>
+          <a:xfrm>
+            <a:off x="3884613" y="8685213"/>
+            <a:ext cx="2971800" cy="458787"/>
+          </a:xfrm>
+          <a:prstGeom prst="rect">
+            <a:avLst/>
+          </a:prstGeom>
+          <a:noFill/>
+          <a:ln>
+            <a:noFill/>
+          </a:ln>
+        </p:spPr>
+        <p:txBody>
+          <a:bodyPr anchorCtr="0" anchor="b" bIns="45700" lIns="91425" spcFirstLastPara="1" rIns="91425" wrap="square" tIns="45700">
+            <a:noAutofit/>
+          </a:bodyPr>
+          <a:lstStyle/>
+          <a:p>
+            <a:pPr indent="0" lvl="0" marL="0" rtl="0" algn="r">
+              <a:spcBef>
+                <a:spcPts val="0"/>
+              </a:spcBef>
+              <a:spcAft>
+                <a:spcPts val="0"/>
+              </a:spcAft>
+              <a:buNone/>
+            </a:pPr>
+            <a:fld id="{00000000-1234-1234-1234-123412341234}" type="slidenum">
+              <a:rPr lang="en-US"/>
+              <a:t>‹#›</a:t>
+            </a:fld>
+            <a:endParaRPr/>
+          </a:p>
+        </p:txBody>
+      </p:sp>
+    </p:spTree>
+  </p:cSld>
+  <p:clrMapOvr>
+    <a:masterClrMapping/>
+  </p:clrMapOvr>
+</p:notes>
+</file>
+
+<file path=ppt/notesSlides/notesSlide9.xml><?xml version="1.0" encoding="utf-8"?>
+<p:notes xmlns:a="http://schemas.openxmlformats.org/drawingml/2006/main" xmlns:r="http://schemas.openxmlformats.org/officeDocument/2006/relationships" xmlns:mc="http://schemas.openxmlformats.org/markup-compatibility/2006" xmlns:mv="urn:schemas-microsoft-com:mac:vml" xmlns:p="http://schemas.openxmlformats.org/presentationml/2006/main" xmlns:c="http://schemas.openxmlformats.org/drawingml/2006/chart" xmlns:dgm="http://schemas.openxmlformats.org/drawingml/2006/diagram" xmlns:o="urn:schemas-microsoft-com:office:office" xmlns:v="urn:schemas-microsoft-com:vml" xmlns:pvml="urn:schemas-microsoft-com:office:powerpoint" xmlns:com="http://schemas.openxmlformats.org/drawingml/2006/compatibility" xmlns:p14="http://schemas.microsoft.com/office/powerpoint/2010/main" xmlns:p15="http://schemas.microsoft.com/office/powerpoint/2012/main" xmlns:ahyp="http://schemas.microsoft.com/office/drawing/2018/hyperlinkcolor" showMasterPhAnim="0" showMasterSp="0">
+  <p:cSld>
+    <p:spTree>
+      <p:nvGrpSpPr>
+        <p:cNvPr id="105" name="Shape 105"/>
+        <p:cNvGrpSpPr/>
+        <p:nvPr/>
+      </p:nvGrpSpPr>
+      <p:grpSpPr>
+        <a:xfrm>
+          <a:off x="0" y="0"/>
+          <a:ext cx="0" cy="0"/>
+          <a:chOff x="0" y="0"/>
+          <a:chExt cx="0" cy="0"/>
+        </a:xfrm>
+      </p:grpSpPr>
+      <p:sp>
+        <p:nvSpPr>
+          <p:cNvPr id="106" name="Google Shape;106;p7:notes"/>
+          <p:cNvSpPr/>
+          <p:nvPr>
+            <p:ph idx="2" type="sldImg"/>
+          </p:nvPr>
+        </p:nvSpPr>
+        <p:spPr>
+          <a:xfrm>
+            <a:off x="685800" y="1143000"/>
+            <a:ext cx="5486400" cy="3086100"/>
+          </a:xfrm>
+          <a:custGeom>
+            <a:rect b="b" l="l" r="r" t="t"/>
+            <a:pathLst>
+              <a:path extrusionOk="0" h="120000" w="120000">
+                <a:moveTo>
+                  <a:pt x="0" y="0"/>
+                </a:moveTo>
+                <a:lnTo>
+                  <a:pt x="120000" y="0"/>
+                </a:lnTo>
+                <a:lnTo>
+                  <a:pt x="120000" y="120000"/>
+                </a:lnTo>
+                <a:lnTo>
+                  <a:pt x="0" y="120000"/>
+                </a:lnTo>
+                <a:close/>
+              </a:path>
+            </a:pathLst>
+          </a:custGeom>
+          <a:noFill/>
+          <a:ln cap="flat" cmpd="sng" w="12700">
+            <a:solidFill>
+              <a:srgbClr val="000000"/>
+            </a:solidFill>
+            <a:prstDash val="solid"/>
+            <a:round/>
+            <a:headEnd len="sm" w="sm" type="none"/>
+            <a:tailEnd len="sm" w="sm" type="none"/>
+          </a:ln>
+        </p:spPr>
+      </p:sp>
+      <p:sp>
+        <p:nvSpPr>
+          <p:cNvPr id="107" name="Google Shape;107;p7:notes"/>
+          <p:cNvSpPr txBox="1"/>
+          <p:nvPr>
+            <p:ph idx="1" type="body"/>
+          </p:nvPr>
+        </p:nvSpPr>
+        <p:spPr>
+          <a:xfrm>
+            <a:off x="685800" y="4400550"/>
+            <a:ext cx="5486400" cy="3600450"/>
+          </a:xfrm>
+          <a:prstGeom prst="rect">
+            <a:avLst/>
+          </a:prstGeom>
+          <a:noFill/>
+          <a:ln>
+            <a:noFill/>
+          </a:ln>
+        </p:spPr>
+        <p:txBody>
+          <a:bodyPr anchorCtr="0" anchor="t" bIns="45700" lIns="91425" spcFirstLastPara="1" rIns="91425" wrap="square" tIns="45700">
+            <a:noAutofit/>
+          </a:bodyPr>
+          <a:lstStyle/>
+          <a:p>
+            <a:pPr indent="0" lvl="0" marL="0" rtl="0" algn="l">
+              <a:spcBef>
+                <a:spcPts val="0"/>
+              </a:spcBef>
+              <a:spcAft>
+                <a:spcPts val="0"/>
+              </a:spcAft>
+              <a:buNone/>
+            </a:pPr>
+            <a:r>
+              <a:rPr lang="en-US"/>
               <a:t>Abbiamo progettato per Giorgio, settantun anni, che legge male i caratteri piccoli, e per Lucia, che fa la domanda per la madre di ottantaquattro. Si risponde a voce, i messaggi vengono letti ad alta voce, testo grande, e al posto dei moduli ci sono oggetti che tutti conoscono. Con i dati aperti del Comune troviamo anche gli uffici più vicini a casa.</a:t>
             </a:r>
             <a:endParaRPr/>
@@ -4149,7 +4308,7 @@
       </p:sp>
       <p:sp>
         <p:nvSpPr>
-          <p:cNvPr id="106" name="Google Shape;106;p7:notes"/>
+          <p:cNvPr id="108" name="Google Shape;108;p7:notes"/>
           <p:cNvSpPr txBox="1"/>
           <p:nvPr>
             <p:ph idx="12" type="sldNum"/>
@@ -5328,6 +5487,62 @@
           </a:p>
         </p:txBody>
       </p:sp>
+      <p:pic>
+        <p:nvPicPr>
+          <p:cNvPr id="22" name="Google Shape;22;h1c30e251418f18d3_1_42"/>
+          <p:cNvPicPr preferRelativeResize="0"/>
+          <p:nvPr/>
+        </p:nvPicPr>
+        <p:blipFill>
+          <a:blip r:embed="rId4">
+            <a:alphaModFix/>
+          </a:blip>
+          <a:stretch>
+            <a:fillRect/>
+          </a:stretch>
+        </p:blipFill>
+        <p:spPr>
+          <a:xfrm>
+            <a:off x="1886674" y="1707400"/>
+            <a:ext cx="274202" cy="274198"/>
+          </a:xfrm>
+          <a:prstGeom prst="rect">
+            <a:avLst/>
+          </a:prstGeom>
+          <a:noFill/>
+          <a:ln>
+            <a:noFill/>
+          </a:ln>
+        </p:spPr>
+      </p:pic>
+      <p:pic>
+        <p:nvPicPr>
+          <p:cNvPr id="23" name="Google Shape;23;h1c30e251418f18d3_1_42"/>
+          <p:cNvPicPr preferRelativeResize="0"/>
+          <p:nvPr/>
+        </p:nvPicPr>
+        <p:blipFill>
+          <a:blip r:embed="rId5">
+            <a:alphaModFix/>
+          </a:blip>
+          <a:stretch>
+            <a:fillRect/>
+          </a:stretch>
+        </p:blipFill>
+        <p:spPr>
+          <a:xfrm>
+            <a:off x="275280" y="179133"/>
+            <a:ext cx="1518400" cy="717075"/>
+          </a:xfrm>
+          <a:prstGeom prst="rect">
+            <a:avLst/>
+          </a:prstGeom>
+          <a:noFill/>
+          <a:ln>
+            <a:noFill/>
+          </a:ln>
+        </p:spPr>
+      </p:pic>
     </p:spTree>
   </p:cSld>
   <p:clrMapOvr>
@@ -5348,7 +5563,7 @@
     </p:bg>
     <p:spTree>
       <p:nvGrpSpPr>
-        <p:cNvPr id="131" name="Shape 131"/>
+        <p:cNvPr id="133" name="Shape 133"/>
         <p:cNvGrpSpPr/>
         <p:nvPr/>
       </p:nvGrpSpPr>
@@ -5362,7 +5577,7 @@
       </p:grpSpPr>
       <p:sp>
         <p:nvSpPr>
-          <p:cNvPr id="132" name="Google Shape;132;p8"/>
+          <p:cNvPr id="134" name="Google Shape;134;p8"/>
           <p:cNvSpPr txBox="1"/>
           <p:nvPr/>
         </p:nvSpPr>
@@ -5425,7 +5640,7 @@
       </p:sp>
       <p:sp>
         <p:nvSpPr>
-          <p:cNvPr id="133" name="Google Shape;133;p8"/>
+          <p:cNvPr id="135" name="Google Shape;135;p8"/>
           <p:cNvSpPr/>
           <p:nvPr/>
         </p:nvSpPr>
@@ -5476,7 +5691,7 @@
       </p:sp>
       <p:sp>
         <p:nvSpPr>
-          <p:cNvPr id="134" name="Google Shape;134;p8"/>
+          <p:cNvPr id="136" name="Google Shape;136;p8"/>
           <p:cNvSpPr/>
           <p:nvPr/>
         </p:nvSpPr>
@@ -5525,7 +5740,7 @@
       </p:sp>
       <p:pic>
         <p:nvPicPr>
-          <p:cNvPr descr="preencoded.png" id="135" name="Google Shape;135;p8"/>
+          <p:cNvPr descr="preencoded.png" id="137" name="Google Shape;137;p8"/>
           <p:cNvPicPr preferRelativeResize="0"/>
           <p:nvPr/>
         </p:nvPicPr>
@@ -5552,7 +5767,7 @@
       </p:pic>
       <p:sp>
         <p:nvSpPr>
-          <p:cNvPr id="136" name="Google Shape;136;p8"/>
+          <p:cNvPr id="138" name="Google Shape;138;p8"/>
           <p:cNvSpPr txBox="1"/>
           <p:nvPr/>
         </p:nvSpPr>
@@ -5615,7 +5830,7 @@
       </p:sp>
       <p:sp>
         <p:nvSpPr>
-          <p:cNvPr id="137" name="Google Shape;137;p8"/>
+          <p:cNvPr id="139" name="Google Shape;139;p8"/>
           <p:cNvSpPr txBox="1"/>
           <p:nvPr/>
         </p:nvSpPr>
@@ -5678,7 +5893,7 @@
       </p:sp>
       <p:sp>
         <p:nvSpPr>
-          <p:cNvPr id="138" name="Google Shape;138;p8"/>
+          <p:cNvPr id="140" name="Google Shape;140;p8"/>
           <p:cNvSpPr txBox="1"/>
           <p:nvPr/>
         </p:nvSpPr>
@@ -5852,7 +6067,7 @@
       </p:sp>
       <p:sp>
         <p:nvSpPr>
-          <p:cNvPr id="139" name="Google Shape;139;p8"/>
+          <p:cNvPr id="141" name="Google Shape;141;p8"/>
           <p:cNvSpPr/>
           <p:nvPr/>
         </p:nvSpPr>
@@ -5903,7 +6118,7 @@
       </p:sp>
       <p:sp>
         <p:nvSpPr>
-          <p:cNvPr id="140" name="Google Shape;140;p8"/>
+          <p:cNvPr id="142" name="Google Shape;142;p8"/>
           <p:cNvSpPr/>
           <p:nvPr/>
         </p:nvSpPr>
@@ -5954,7 +6169,7 @@
       </p:sp>
       <p:sp>
         <p:nvSpPr>
-          <p:cNvPr id="141" name="Google Shape;141;p8"/>
+          <p:cNvPr id="143" name="Google Shape;143;p8"/>
           <p:cNvSpPr/>
           <p:nvPr/>
         </p:nvSpPr>
@@ -6003,7 +6218,7 @@
       </p:sp>
       <p:pic>
         <p:nvPicPr>
-          <p:cNvPr descr="preencoded.png" id="142" name="Google Shape;142;p8"/>
+          <p:cNvPr descr="preencoded.png" id="144" name="Google Shape;144;p8"/>
           <p:cNvPicPr preferRelativeResize="0"/>
           <p:nvPr/>
         </p:nvPicPr>
@@ -6030,7 +6245,7 @@
       </p:pic>
       <p:sp>
         <p:nvSpPr>
-          <p:cNvPr id="143" name="Google Shape;143;p8"/>
+          <p:cNvPr id="145" name="Google Shape;145;p8"/>
           <p:cNvSpPr txBox="1"/>
           <p:nvPr/>
         </p:nvSpPr>
@@ -6093,7 +6308,7 @@
       </p:sp>
       <p:sp>
         <p:nvSpPr>
-          <p:cNvPr id="144" name="Google Shape;144;p8"/>
+          <p:cNvPr id="146" name="Google Shape;146;p8"/>
           <p:cNvSpPr txBox="1"/>
           <p:nvPr/>
         </p:nvSpPr>
@@ -6156,7 +6371,7 @@
       </p:sp>
       <p:sp>
         <p:nvSpPr>
-          <p:cNvPr id="145" name="Google Shape;145;p8"/>
+          <p:cNvPr id="147" name="Google Shape;147;p8"/>
           <p:cNvSpPr txBox="1"/>
           <p:nvPr/>
         </p:nvSpPr>
@@ -6293,7 +6508,7 @@
       </p:sp>
       <p:sp>
         <p:nvSpPr>
-          <p:cNvPr id="146" name="Google Shape;146;p8"/>
+          <p:cNvPr id="148" name="Google Shape;148;p8"/>
           <p:cNvSpPr/>
           <p:nvPr/>
         </p:nvSpPr>
@@ -6344,7 +6559,7 @@
       </p:sp>
       <p:sp>
         <p:nvSpPr>
-          <p:cNvPr id="147" name="Google Shape;147;p8"/>
+          <p:cNvPr id="149" name="Google Shape;149;p8"/>
           <p:cNvSpPr/>
           <p:nvPr/>
         </p:nvSpPr>
@@ -6395,7 +6610,7 @@
       </p:sp>
       <p:sp>
         <p:nvSpPr>
-          <p:cNvPr id="148" name="Google Shape;148;p8"/>
+          <p:cNvPr id="150" name="Google Shape;150;p8"/>
           <p:cNvSpPr/>
           <p:nvPr/>
         </p:nvSpPr>
@@ -6444,7 +6659,7 @@
       </p:sp>
       <p:pic>
         <p:nvPicPr>
-          <p:cNvPr descr="preencoded.png" id="149" name="Google Shape;149;p8"/>
+          <p:cNvPr descr="preencoded.png" id="151" name="Google Shape;151;p8"/>
           <p:cNvPicPr preferRelativeResize="0"/>
           <p:nvPr/>
         </p:nvPicPr>
@@ -6471,7 +6686,7 @@
       </p:pic>
       <p:sp>
         <p:nvSpPr>
-          <p:cNvPr id="150" name="Google Shape;150;p8"/>
+          <p:cNvPr id="152" name="Google Shape;152;p8"/>
           <p:cNvSpPr txBox="1"/>
           <p:nvPr/>
         </p:nvSpPr>
@@ -6534,7 +6749,7 @@
       </p:sp>
       <p:sp>
         <p:nvSpPr>
-          <p:cNvPr id="151" name="Google Shape;151;p8"/>
+          <p:cNvPr id="153" name="Google Shape;153;p8"/>
           <p:cNvSpPr txBox="1"/>
           <p:nvPr/>
         </p:nvSpPr>
@@ -6597,7 +6812,7 @@
       </p:sp>
       <p:sp>
         <p:nvSpPr>
-          <p:cNvPr id="152" name="Google Shape;152;p8"/>
+          <p:cNvPr id="154" name="Google Shape;154;p8"/>
           <p:cNvSpPr txBox="1"/>
           <p:nvPr/>
         </p:nvSpPr>
@@ -6734,7 +6949,7 @@
       </p:sp>
       <p:sp>
         <p:nvSpPr>
-          <p:cNvPr id="153" name="Google Shape;153;p8"/>
+          <p:cNvPr id="155" name="Google Shape;155;p8"/>
           <p:cNvSpPr/>
           <p:nvPr/>
         </p:nvSpPr>
@@ -6785,7 +7000,7 @@
       </p:sp>
       <p:sp>
         <p:nvSpPr>
-          <p:cNvPr id="154" name="Google Shape;154;p8"/>
+          <p:cNvPr id="156" name="Google Shape;156;p8"/>
           <p:cNvSpPr txBox="1"/>
           <p:nvPr/>
         </p:nvSpPr>
@@ -6860,7 +7075,7 @@
       </p:sp>
       <p:sp>
         <p:nvSpPr>
-          <p:cNvPr id="155" name="Google Shape;155;p8"/>
+          <p:cNvPr id="157" name="Google Shape;157;p8"/>
           <p:cNvSpPr txBox="1"/>
           <p:nvPr/>
         </p:nvSpPr>
@@ -6941,7 +7156,7 @@
     </p:bg>
     <p:spTree>
       <p:nvGrpSpPr>
-        <p:cNvPr id="160" name="Shape 160"/>
+        <p:cNvPr id="162" name="Shape 162"/>
         <p:cNvGrpSpPr/>
         <p:nvPr/>
       </p:nvGrpSpPr>
@@ -6955,7 +7170,7 @@
       </p:grpSpPr>
       <p:sp>
         <p:nvSpPr>
-          <p:cNvPr id="161" name="Google Shape;161;p9"/>
+          <p:cNvPr id="163" name="Google Shape;163;p9"/>
           <p:cNvSpPr txBox="1"/>
           <p:nvPr/>
         </p:nvSpPr>
@@ -7018,7 +7233,7 @@
       </p:sp>
       <p:sp>
         <p:nvSpPr>
-          <p:cNvPr id="162" name="Google Shape;162;p9"/>
+          <p:cNvPr id="164" name="Google Shape;164;p9"/>
           <p:cNvSpPr/>
           <p:nvPr/>
         </p:nvSpPr>
@@ -7067,7 +7282,7 @@
       </p:sp>
       <p:sp>
         <p:nvSpPr>
-          <p:cNvPr id="163" name="Google Shape;163;p9"/>
+          <p:cNvPr id="165" name="Google Shape;165;p9"/>
           <p:cNvSpPr txBox="1"/>
           <p:nvPr/>
         </p:nvSpPr>
@@ -7130,7 +7345,7 @@
       </p:sp>
       <p:sp>
         <p:nvSpPr>
-          <p:cNvPr id="164" name="Google Shape;164;p9"/>
+          <p:cNvPr id="166" name="Google Shape;166;p9"/>
           <p:cNvSpPr/>
           <p:nvPr/>
         </p:nvSpPr>
@@ -7179,7 +7394,7 @@
       </p:sp>
       <p:sp>
         <p:nvSpPr>
-          <p:cNvPr id="165" name="Google Shape;165;p9"/>
+          <p:cNvPr id="167" name="Google Shape;167;p9"/>
           <p:cNvSpPr txBox="1"/>
           <p:nvPr/>
         </p:nvSpPr>
@@ -7242,7 +7457,7 @@
       </p:sp>
       <p:sp>
         <p:nvSpPr>
-          <p:cNvPr id="166" name="Google Shape;166;p9"/>
+          <p:cNvPr id="168" name="Google Shape;168;p9"/>
           <p:cNvSpPr/>
           <p:nvPr/>
         </p:nvSpPr>
@@ -7291,7 +7506,7 @@
       </p:sp>
       <p:sp>
         <p:nvSpPr>
-          <p:cNvPr id="167" name="Google Shape;167;p9"/>
+          <p:cNvPr id="169" name="Google Shape;169;p9"/>
           <p:cNvSpPr txBox="1"/>
           <p:nvPr/>
         </p:nvSpPr>
@@ -7354,7 +7569,7 @@
       </p:sp>
       <p:sp>
         <p:nvSpPr>
-          <p:cNvPr id="168" name="Google Shape;168;p9"/>
+          <p:cNvPr id="170" name="Google Shape;170;p9"/>
           <p:cNvSpPr/>
           <p:nvPr/>
         </p:nvSpPr>
@@ -7403,7 +7618,7 @@
       </p:sp>
       <p:sp>
         <p:nvSpPr>
-          <p:cNvPr id="169" name="Google Shape;169;p9"/>
+          <p:cNvPr id="171" name="Google Shape;171;p9"/>
           <p:cNvSpPr txBox="1"/>
           <p:nvPr/>
         </p:nvSpPr>
@@ -7466,7 +7681,7 @@
       </p:sp>
       <p:sp>
         <p:nvSpPr>
-          <p:cNvPr id="170" name="Google Shape;170;p9"/>
+          <p:cNvPr id="172" name="Google Shape;172;p9"/>
           <p:cNvSpPr/>
           <p:nvPr/>
         </p:nvSpPr>
@@ -7515,7 +7730,7 @@
       </p:sp>
       <p:sp>
         <p:nvSpPr>
-          <p:cNvPr id="171" name="Google Shape;171;p9"/>
+          <p:cNvPr id="173" name="Google Shape;173;p9"/>
           <p:cNvSpPr txBox="1"/>
           <p:nvPr/>
         </p:nvSpPr>
@@ -7578,7 +7793,7 @@
       </p:sp>
       <p:sp>
         <p:nvSpPr>
-          <p:cNvPr id="172" name="Google Shape;172;p9"/>
+          <p:cNvPr id="174" name="Google Shape;174;p9"/>
           <p:cNvSpPr/>
           <p:nvPr/>
         </p:nvSpPr>
@@ -7627,7 +7842,7 @@
       </p:sp>
       <p:sp>
         <p:nvSpPr>
-          <p:cNvPr id="173" name="Google Shape;173;p9"/>
+          <p:cNvPr id="175" name="Google Shape;175;p9"/>
           <p:cNvSpPr/>
           <p:nvPr/>
         </p:nvSpPr>
@@ -7676,7 +7891,7 @@
       </p:sp>
       <p:sp>
         <p:nvSpPr>
-          <p:cNvPr id="174" name="Google Shape;174;p9"/>
+          <p:cNvPr id="176" name="Google Shape;176;p9"/>
           <p:cNvSpPr txBox="1"/>
           <p:nvPr/>
         </p:nvSpPr>
@@ -7739,7 +7954,7 @@
       </p:sp>
       <p:sp>
         <p:nvSpPr>
-          <p:cNvPr id="175" name="Google Shape;175;p9"/>
+          <p:cNvPr id="177" name="Google Shape;177;p9"/>
           <p:cNvSpPr/>
           <p:nvPr/>
         </p:nvSpPr>
@@ -7788,7 +8003,7 @@
       </p:sp>
       <p:sp>
         <p:nvSpPr>
-          <p:cNvPr id="176" name="Google Shape;176;p9"/>
+          <p:cNvPr id="178" name="Google Shape;178;p9"/>
           <p:cNvSpPr txBox="1"/>
           <p:nvPr/>
         </p:nvSpPr>
@@ -7851,7 +8066,7 @@
       </p:sp>
       <p:sp>
         <p:nvSpPr>
-          <p:cNvPr id="177" name="Google Shape;177;p9"/>
+          <p:cNvPr id="179" name="Google Shape;179;p9"/>
           <p:cNvSpPr txBox="1"/>
           <p:nvPr/>
         </p:nvSpPr>
@@ -7914,7 +8129,7 @@
       </p:sp>
       <p:sp>
         <p:nvSpPr>
-          <p:cNvPr id="178" name="Google Shape;178;p9"/>
+          <p:cNvPr id="180" name="Google Shape;180;p9"/>
           <p:cNvSpPr/>
           <p:nvPr/>
         </p:nvSpPr>
@@ -7965,7 +8180,7 @@
       </p:sp>
       <p:sp>
         <p:nvSpPr>
-          <p:cNvPr id="179" name="Google Shape;179;p9"/>
+          <p:cNvPr id="181" name="Google Shape;181;p9"/>
           <p:cNvSpPr txBox="1"/>
           <p:nvPr/>
         </p:nvSpPr>
@@ -8028,7 +8243,7 @@
       </p:sp>
       <p:sp>
         <p:nvSpPr>
-          <p:cNvPr id="180" name="Google Shape;180;p9"/>
+          <p:cNvPr id="182" name="Google Shape;182;p9"/>
           <p:cNvSpPr txBox="1"/>
           <p:nvPr/>
         </p:nvSpPr>
@@ -8091,7 +8306,7 @@
       </p:sp>
       <p:sp>
         <p:nvSpPr>
-          <p:cNvPr id="181" name="Google Shape;181;p9"/>
+          <p:cNvPr id="183" name="Google Shape;183;p9"/>
           <p:cNvSpPr/>
           <p:nvPr/>
         </p:nvSpPr>
@@ -8142,7 +8357,7 @@
       </p:sp>
       <p:sp>
         <p:nvSpPr>
-          <p:cNvPr id="182" name="Google Shape;182;p9"/>
+          <p:cNvPr id="184" name="Google Shape;184;p9"/>
           <p:cNvSpPr txBox="1"/>
           <p:nvPr/>
         </p:nvSpPr>
@@ -8205,7 +8420,7 @@
       </p:sp>
       <p:sp>
         <p:nvSpPr>
-          <p:cNvPr id="183" name="Google Shape;183;p9"/>
+          <p:cNvPr id="185" name="Google Shape;185;p9"/>
           <p:cNvSpPr txBox="1"/>
           <p:nvPr/>
         </p:nvSpPr>
@@ -8268,7 +8483,7 @@
       </p:sp>
       <p:sp>
         <p:nvSpPr>
-          <p:cNvPr id="184" name="Google Shape;184;p9"/>
+          <p:cNvPr id="186" name="Google Shape;186;p9"/>
           <p:cNvSpPr/>
           <p:nvPr/>
         </p:nvSpPr>
@@ -8319,7 +8534,7 @@
       </p:sp>
       <p:sp>
         <p:nvSpPr>
-          <p:cNvPr id="185" name="Google Shape;185;p9"/>
+          <p:cNvPr id="187" name="Google Shape;187;p9"/>
           <p:cNvSpPr txBox="1"/>
           <p:nvPr/>
         </p:nvSpPr>
@@ -8382,7 +8597,7 @@
       </p:sp>
       <p:sp>
         <p:nvSpPr>
-          <p:cNvPr id="186" name="Google Shape;186;p9"/>
+          <p:cNvPr id="188" name="Google Shape;188;p9"/>
           <p:cNvSpPr txBox="1"/>
           <p:nvPr/>
         </p:nvSpPr>
@@ -8445,7 +8660,7 @@
       </p:sp>
       <p:sp>
         <p:nvSpPr>
-          <p:cNvPr id="187" name="Google Shape;187;p9"/>
+          <p:cNvPr id="189" name="Google Shape;189;p9"/>
           <p:cNvSpPr/>
           <p:nvPr/>
         </p:nvSpPr>
@@ -8496,7 +8711,7 @@
       </p:sp>
       <p:sp>
         <p:nvSpPr>
-          <p:cNvPr id="188" name="Google Shape;188;p9"/>
+          <p:cNvPr id="190" name="Google Shape;190;p9"/>
           <p:cNvSpPr txBox="1"/>
           <p:nvPr/>
         </p:nvSpPr>
@@ -8559,7 +8774,7 @@
       </p:sp>
       <p:sp>
         <p:nvSpPr>
-          <p:cNvPr id="189" name="Google Shape;189;p9"/>
+          <p:cNvPr id="191" name="Google Shape;191;p9"/>
           <p:cNvSpPr txBox="1"/>
           <p:nvPr/>
         </p:nvSpPr>
@@ -8622,7 +8837,7 @@
       </p:sp>
       <p:sp>
         <p:nvSpPr>
-          <p:cNvPr id="190" name="Google Shape;190;p9"/>
+          <p:cNvPr id="192" name="Google Shape;192;p9"/>
           <p:cNvSpPr/>
           <p:nvPr/>
         </p:nvSpPr>
@@ -8673,7 +8888,7 @@
       </p:sp>
       <p:sp>
         <p:nvSpPr>
-          <p:cNvPr id="191" name="Google Shape;191;p9"/>
+          <p:cNvPr id="193" name="Google Shape;193;p9"/>
           <p:cNvSpPr txBox="1"/>
           <p:nvPr/>
         </p:nvSpPr>
@@ -8736,7 +8951,7 @@
       </p:sp>
       <p:sp>
         <p:nvSpPr>
-          <p:cNvPr id="192" name="Google Shape;192;p9"/>
+          <p:cNvPr id="194" name="Google Shape;194;p9"/>
           <p:cNvSpPr txBox="1"/>
           <p:nvPr/>
         </p:nvSpPr>
@@ -8799,7 +9014,7 @@
       </p:sp>
       <p:sp>
         <p:nvSpPr>
-          <p:cNvPr id="193" name="Google Shape;193;p9"/>
+          <p:cNvPr id="195" name="Google Shape;195;p9"/>
           <p:cNvSpPr txBox="1"/>
           <p:nvPr/>
         </p:nvSpPr>
@@ -8880,7 +9095,7 @@
     </p:bg>
     <p:spTree>
       <p:nvGrpSpPr>
-        <p:cNvPr id="198" name="Shape 198"/>
+        <p:cNvPr id="200" name="Shape 200"/>
         <p:cNvGrpSpPr/>
         <p:nvPr/>
       </p:nvGrpSpPr>
@@ -8894,7 +9109,7 @@
       </p:grpSpPr>
       <p:sp>
         <p:nvSpPr>
-          <p:cNvPr id="199" name="Google Shape;199;h1c30e251418f18d3_1_24"/>
+          <p:cNvPr id="201" name="Google Shape;201;h1c30e251418f18d3_1_24"/>
           <p:cNvSpPr txBox="1"/>
           <p:nvPr/>
         </p:nvSpPr>
@@ -8953,7 +9168,7 @@
       </p:sp>
       <p:pic>
         <p:nvPicPr>
-          <p:cNvPr id="200" name="Google Shape;200;h1c30e251418f18d3_1_24" title="Screenshot 2026-10-03 at 15.25.11.png"/>
+          <p:cNvPr id="202" name="Google Shape;202;h1c30e251418f18d3_1_24" title="Screenshot 2026-10-03 at 15.25.11.png"/>
           <p:cNvPicPr preferRelativeResize="0"/>
           <p:nvPr/>
         </p:nvPicPr>
@@ -8998,7 +9213,7 @@
     </p:bg>
     <p:spTree>
       <p:nvGrpSpPr>
-        <p:cNvPr id="205" name="Shape 205"/>
+        <p:cNvPr id="207" name="Shape 207"/>
         <p:cNvGrpSpPr/>
         <p:nvPr/>
       </p:nvGrpSpPr>
@@ -9012,7 +9227,7 @@
       </p:grpSpPr>
       <p:sp>
         <p:nvSpPr>
-          <p:cNvPr id="206" name="Google Shape;206;p10"/>
+          <p:cNvPr id="208" name="Google Shape;208;p10"/>
           <p:cNvSpPr txBox="1"/>
           <p:nvPr/>
         </p:nvSpPr>
@@ -9075,7 +9290,7 @@
       </p:sp>
       <p:sp>
         <p:nvSpPr>
-          <p:cNvPr id="207" name="Google Shape;207;p10"/>
+          <p:cNvPr id="209" name="Google Shape;209;p10"/>
           <p:cNvSpPr/>
           <p:nvPr/>
         </p:nvSpPr>
@@ -9126,7 +9341,7 @@
       </p:sp>
       <p:sp>
         <p:nvSpPr>
-          <p:cNvPr id="208" name="Google Shape;208;p10"/>
+          <p:cNvPr id="210" name="Google Shape;210;p10"/>
           <p:cNvSpPr/>
           <p:nvPr/>
         </p:nvSpPr>
@@ -9175,7 +9390,7 @@
       </p:sp>
       <p:pic>
         <p:nvPicPr>
-          <p:cNvPr descr="preencoded.png" id="209" name="Google Shape;209;p10"/>
+          <p:cNvPr descr="preencoded.png" id="211" name="Google Shape;211;p10"/>
           <p:cNvPicPr preferRelativeResize="0"/>
           <p:nvPr/>
         </p:nvPicPr>
@@ -9202,7 +9417,7 @@
       </p:pic>
       <p:sp>
         <p:nvSpPr>
-          <p:cNvPr id="210" name="Google Shape;210;p10"/>
+          <p:cNvPr id="212" name="Google Shape;212;p10"/>
           <p:cNvSpPr txBox="1"/>
           <p:nvPr/>
         </p:nvSpPr>
@@ -9265,7 +9480,7 @@
       </p:sp>
       <p:sp>
         <p:nvSpPr>
-          <p:cNvPr id="211" name="Google Shape;211;p10"/>
+          <p:cNvPr id="213" name="Google Shape;213;p10"/>
           <p:cNvSpPr txBox="1"/>
           <p:nvPr/>
         </p:nvSpPr>
@@ -9328,7 +9543,7 @@
       </p:sp>
       <p:sp>
         <p:nvSpPr>
-          <p:cNvPr id="212" name="Google Shape;212;p10"/>
+          <p:cNvPr id="214" name="Google Shape;214;p10"/>
           <p:cNvSpPr/>
           <p:nvPr/>
         </p:nvSpPr>
@@ -9379,7 +9594,7 @@
       </p:sp>
       <p:sp>
         <p:nvSpPr>
-          <p:cNvPr id="213" name="Google Shape;213;p10"/>
+          <p:cNvPr id="215" name="Google Shape;215;p10"/>
           <p:cNvSpPr/>
           <p:nvPr/>
         </p:nvSpPr>
@@ -9428,7 +9643,7 @@
       </p:sp>
       <p:pic>
         <p:nvPicPr>
-          <p:cNvPr descr="preencoded.png" id="214" name="Google Shape;214;p10"/>
+          <p:cNvPr descr="preencoded.png" id="216" name="Google Shape;216;p10"/>
           <p:cNvPicPr preferRelativeResize="0"/>
           <p:nvPr/>
         </p:nvPicPr>
@@ -9455,7 +9670,7 @@
       </p:pic>
       <p:sp>
         <p:nvSpPr>
-          <p:cNvPr id="215" name="Google Shape;215;p10"/>
+          <p:cNvPr id="217" name="Google Shape;217;p10"/>
           <p:cNvSpPr txBox="1"/>
           <p:nvPr/>
         </p:nvSpPr>
@@ -9526,7 +9741,7 @@
       </p:sp>
       <p:sp>
         <p:nvSpPr>
-          <p:cNvPr id="216" name="Google Shape;216;p10"/>
+          <p:cNvPr id="218" name="Google Shape;218;p10"/>
           <p:cNvSpPr txBox="1"/>
           <p:nvPr/>
         </p:nvSpPr>
@@ -9608,7 +9823,7 @@
       </p:sp>
       <p:sp>
         <p:nvSpPr>
-          <p:cNvPr id="217" name="Google Shape;217;p10"/>
+          <p:cNvPr id="219" name="Google Shape;219;p10"/>
           <p:cNvSpPr/>
           <p:nvPr/>
         </p:nvSpPr>
@@ -9659,7 +9874,7 @@
       </p:sp>
       <p:sp>
         <p:nvSpPr>
-          <p:cNvPr id="218" name="Google Shape;218;p10"/>
+          <p:cNvPr id="220" name="Google Shape;220;p10"/>
           <p:cNvSpPr/>
           <p:nvPr/>
         </p:nvSpPr>
@@ -9708,7 +9923,7 @@
       </p:sp>
       <p:pic>
         <p:nvPicPr>
-          <p:cNvPr descr="preencoded.png" id="219" name="Google Shape;219;p10"/>
+          <p:cNvPr descr="preencoded.png" id="221" name="Google Shape;221;p10"/>
           <p:cNvPicPr preferRelativeResize="0"/>
           <p:nvPr/>
         </p:nvPicPr>
@@ -9735,7 +9950,7 @@
       </p:pic>
       <p:sp>
         <p:nvSpPr>
-          <p:cNvPr id="220" name="Google Shape;220;p10"/>
+          <p:cNvPr id="222" name="Google Shape;222;p10"/>
           <p:cNvSpPr txBox="1"/>
           <p:nvPr/>
         </p:nvSpPr>
@@ -9798,7 +10013,7 @@
       </p:sp>
       <p:sp>
         <p:nvSpPr>
-          <p:cNvPr id="221" name="Google Shape;221;p10"/>
+          <p:cNvPr id="223" name="Google Shape;223;p10"/>
           <p:cNvSpPr txBox="1"/>
           <p:nvPr/>
         </p:nvSpPr>
@@ -9861,7 +10076,7 @@
       </p:sp>
       <p:sp>
         <p:nvSpPr>
-          <p:cNvPr id="222" name="Google Shape;222;p10"/>
+          <p:cNvPr id="224" name="Google Shape;224;p10"/>
           <p:cNvSpPr/>
           <p:nvPr/>
         </p:nvSpPr>
@@ -9912,7 +10127,7 @@
       </p:sp>
       <p:sp>
         <p:nvSpPr>
-          <p:cNvPr id="223" name="Google Shape;223;p10"/>
+          <p:cNvPr id="225" name="Google Shape;225;p10"/>
           <p:cNvSpPr/>
           <p:nvPr/>
         </p:nvSpPr>
@@ -9961,7 +10176,7 @@
       </p:sp>
       <p:pic>
         <p:nvPicPr>
-          <p:cNvPr descr="preencoded.png" id="224" name="Google Shape;224;p10"/>
+          <p:cNvPr descr="preencoded.png" id="226" name="Google Shape;226;p10"/>
           <p:cNvPicPr preferRelativeResize="0"/>
           <p:nvPr/>
         </p:nvPicPr>
@@ -9988,7 +10203,7 @@
       </p:pic>
       <p:sp>
         <p:nvSpPr>
-          <p:cNvPr id="225" name="Google Shape;225;p10"/>
+          <p:cNvPr id="227" name="Google Shape;227;p10"/>
           <p:cNvSpPr txBox="1"/>
           <p:nvPr/>
         </p:nvSpPr>
@@ -10051,7 +10266,7 @@
       </p:sp>
       <p:sp>
         <p:nvSpPr>
-          <p:cNvPr id="226" name="Google Shape;226;p10"/>
+          <p:cNvPr id="228" name="Google Shape;228;p10"/>
           <p:cNvSpPr txBox="1"/>
           <p:nvPr/>
         </p:nvSpPr>
@@ -10114,7 +10329,7 @@
       </p:sp>
       <p:sp>
         <p:nvSpPr>
-          <p:cNvPr id="227" name="Google Shape;227;p10"/>
+          <p:cNvPr id="229" name="Google Shape;229;p10"/>
           <p:cNvSpPr/>
           <p:nvPr/>
         </p:nvSpPr>
@@ -10165,7 +10380,7 @@
       </p:sp>
       <p:sp>
         <p:nvSpPr>
-          <p:cNvPr id="228" name="Google Shape;228;p10"/>
+          <p:cNvPr id="230" name="Google Shape;230;p10"/>
           <p:cNvSpPr/>
           <p:nvPr/>
         </p:nvSpPr>
@@ -10214,7 +10429,7 @@
       </p:sp>
       <p:pic>
         <p:nvPicPr>
-          <p:cNvPr descr="preencoded.png" id="229" name="Google Shape;229;p10"/>
+          <p:cNvPr descr="preencoded.png" id="231" name="Google Shape;231;p10"/>
           <p:cNvPicPr preferRelativeResize="0"/>
           <p:nvPr/>
         </p:nvPicPr>
@@ -10241,7 +10456,7 @@
       </p:pic>
       <p:sp>
         <p:nvSpPr>
-          <p:cNvPr id="230" name="Google Shape;230;p10"/>
+          <p:cNvPr id="232" name="Google Shape;232;p10"/>
           <p:cNvSpPr txBox="1"/>
           <p:nvPr/>
         </p:nvSpPr>
@@ -10304,7 +10519,7 @@
       </p:sp>
       <p:sp>
         <p:nvSpPr>
-          <p:cNvPr id="231" name="Google Shape;231;p10"/>
+          <p:cNvPr id="233" name="Google Shape;233;p10"/>
           <p:cNvSpPr txBox="1"/>
           <p:nvPr/>
         </p:nvSpPr>
@@ -10367,7 +10582,7 @@
       </p:sp>
       <p:sp>
         <p:nvSpPr>
-          <p:cNvPr id="232" name="Google Shape;232;p10"/>
+          <p:cNvPr id="234" name="Google Shape;234;p10"/>
           <p:cNvSpPr/>
           <p:nvPr/>
         </p:nvSpPr>
@@ -10418,7 +10633,7 @@
       </p:sp>
       <p:sp>
         <p:nvSpPr>
-          <p:cNvPr id="233" name="Google Shape;233;p10"/>
+          <p:cNvPr id="235" name="Google Shape;235;p10"/>
           <p:cNvSpPr/>
           <p:nvPr/>
         </p:nvSpPr>
@@ -10467,7 +10682,7 @@
       </p:sp>
       <p:pic>
         <p:nvPicPr>
-          <p:cNvPr descr="preencoded.png" id="234" name="Google Shape;234;p10"/>
+          <p:cNvPr descr="preencoded.png" id="236" name="Google Shape;236;p10"/>
           <p:cNvPicPr preferRelativeResize="0"/>
           <p:nvPr/>
         </p:nvPicPr>
@@ -10494,7 +10709,7 @@
       </p:pic>
       <p:sp>
         <p:nvSpPr>
-          <p:cNvPr id="235" name="Google Shape;235;p10"/>
+          <p:cNvPr id="237" name="Google Shape;237;p10"/>
           <p:cNvSpPr txBox="1"/>
           <p:nvPr/>
         </p:nvSpPr>
@@ -10557,7 +10772,7 @@
       </p:sp>
       <p:sp>
         <p:nvSpPr>
-          <p:cNvPr id="236" name="Google Shape;236;p10"/>
+          <p:cNvPr id="238" name="Google Shape;238;p10"/>
           <p:cNvSpPr txBox="1"/>
           <p:nvPr/>
         </p:nvSpPr>
@@ -10620,7 +10835,7 @@
       </p:sp>
       <p:sp>
         <p:nvSpPr>
-          <p:cNvPr id="237" name="Google Shape;237;p10"/>
+          <p:cNvPr id="239" name="Google Shape;239;p10"/>
           <p:cNvSpPr/>
           <p:nvPr/>
         </p:nvSpPr>
@@ -10671,7 +10886,7 @@
       </p:sp>
       <p:sp>
         <p:nvSpPr>
-          <p:cNvPr id="238" name="Google Shape;238;p10"/>
+          <p:cNvPr id="240" name="Google Shape;240;p10"/>
           <p:cNvSpPr txBox="1"/>
           <p:nvPr/>
         </p:nvSpPr>
@@ -10746,7 +10961,7 @@
       </p:sp>
       <p:sp>
         <p:nvSpPr>
-          <p:cNvPr id="239" name="Google Shape;239;p10"/>
+          <p:cNvPr id="241" name="Google Shape;241;p10"/>
           <p:cNvSpPr txBox="1"/>
           <p:nvPr/>
         </p:nvSpPr>
@@ -10827,7 +11042,7 @@
     </p:bg>
     <p:spTree>
       <p:nvGrpSpPr>
-        <p:cNvPr id="244" name="Shape 244"/>
+        <p:cNvPr id="246" name="Shape 246"/>
         <p:cNvGrpSpPr/>
         <p:nvPr/>
       </p:nvGrpSpPr>
@@ -10841,7 +11056,7 @@
       </p:grpSpPr>
       <p:sp>
         <p:nvSpPr>
-          <p:cNvPr id="245" name="Google Shape;245;p11"/>
+          <p:cNvPr id="247" name="Google Shape;247;p11"/>
           <p:cNvSpPr txBox="1"/>
           <p:nvPr/>
         </p:nvSpPr>
@@ -10904,7 +11119,7 @@
       </p:sp>
       <p:sp>
         <p:nvSpPr>
-          <p:cNvPr id="246" name="Google Shape;246;p11"/>
+          <p:cNvPr id="248" name="Google Shape;248;p11"/>
           <p:cNvSpPr/>
           <p:nvPr/>
         </p:nvSpPr>
@@ -10955,7 +11170,7 @@
       </p:sp>
       <p:sp>
         <p:nvSpPr>
-          <p:cNvPr id="247" name="Google Shape;247;p11"/>
+          <p:cNvPr id="249" name="Google Shape;249;p11"/>
           <p:cNvSpPr/>
           <p:nvPr/>
         </p:nvSpPr>
@@ -11004,7 +11219,7 @@
       </p:sp>
       <p:pic>
         <p:nvPicPr>
-          <p:cNvPr descr="preencoded.png" id="248" name="Google Shape;248;p11"/>
+          <p:cNvPr descr="preencoded.png" id="250" name="Google Shape;250;p11"/>
           <p:cNvPicPr preferRelativeResize="0"/>
           <p:nvPr/>
         </p:nvPicPr>
@@ -11031,7 +11246,7 @@
       </p:pic>
       <p:sp>
         <p:nvSpPr>
-          <p:cNvPr id="249" name="Google Shape;249;p11"/>
+          <p:cNvPr id="251" name="Google Shape;251;p11"/>
           <p:cNvSpPr txBox="1"/>
           <p:nvPr/>
         </p:nvSpPr>
@@ -11094,7 +11309,7 @@
       </p:sp>
       <p:sp>
         <p:nvSpPr>
-          <p:cNvPr id="250" name="Google Shape;250;p11"/>
+          <p:cNvPr id="252" name="Google Shape;252;p11"/>
           <p:cNvSpPr txBox="1"/>
           <p:nvPr/>
         </p:nvSpPr>
@@ -11231,7 +11446,7 @@
       </p:sp>
       <p:sp>
         <p:nvSpPr>
-          <p:cNvPr id="251" name="Google Shape;251;p11"/>
+          <p:cNvPr id="253" name="Google Shape;253;p11"/>
           <p:cNvSpPr/>
           <p:nvPr/>
         </p:nvSpPr>
@@ -11282,7 +11497,7 @@
       </p:sp>
       <p:sp>
         <p:nvSpPr>
-          <p:cNvPr id="252" name="Google Shape;252;p11"/>
+          <p:cNvPr id="254" name="Google Shape;254;p11"/>
           <p:cNvSpPr/>
           <p:nvPr/>
         </p:nvSpPr>
@@ -11331,7 +11546,7 @@
       </p:sp>
       <p:pic>
         <p:nvPicPr>
-          <p:cNvPr descr="preencoded.png" id="253" name="Google Shape;253;p11"/>
+          <p:cNvPr descr="preencoded.png" id="255" name="Google Shape;255;p11"/>
           <p:cNvPicPr preferRelativeResize="0"/>
           <p:nvPr/>
         </p:nvPicPr>
@@ -11358,7 +11573,7 @@
       </p:pic>
       <p:sp>
         <p:nvSpPr>
-          <p:cNvPr id="254" name="Google Shape;254;p11"/>
+          <p:cNvPr id="256" name="Google Shape;256;p11"/>
           <p:cNvSpPr txBox="1"/>
           <p:nvPr/>
         </p:nvSpPr>
@@ -11421,7 +11636,7 @@
       </p:sp>
       <p:sp>
         <p:nvSpPr>
-          <p:cNvPr id="255" name="Google Shape;255;p11"/>
+          <p:cNvPr id="257" name="Google Shape;257;p11"/>
           <p:cNvSpPr txBox="1"/>
           <p:nvPr/>
         </p:nvSpPr>
@@ -11558,7 +11773,7 @@
       </p:sp>
       <p:sp>
         <p:nvSpPr>
-          <p:cNvPr id="256" name="Google Shape;256;p11"/>
+          <p:cNvPr id="258" name="Google Shape;258;p11"/>
           <p:cNvSpPr/>
           <p:nvPr/>
         </p:nvSpPr>
@@ -11609,7 +11824,7 @@
       </p:sp>
       <p:sp>
         <p:nvSpPr>
-          <p:cNvPr id="257" name="Google Shape;257;p11"/>
+          <p:cNvPr id="259" name="Google Shape;259;p11"/>
           <p:cNvSpPr/>
           <p:nvPr/>
         </p:nvSpPr>
@@ -11658,7 +11873,7 @@
       </p:sp>
       <p:pic>
         <p:nvPicPr>
-          <p:cNvPr descr="preencoded.png" id="258" name="Google Shape;258;p11"/>
+          <p:cNvPr descr="preencoded.png" id="260" name="Google Shape;260;p11"/>
           <p:cNvPicPr preferRelativeResize="0"/>
           <p:nvPr/>
         </p:nvPicPr>
@@ -11685,7 +11900,7 @@
       </p:pic>
       <p:sp>
         <p:nvSpPr>
-          <p:cNvPr id="259" name="Google Shape;259;p11"/>
+          <p:cNvPr id="261" name="Google Shape;261;p11"/>
           <p:cNvSpPr txBox="1"/>
           <p:nvPr/>
         </p:nvSpPr>
@@ -11748,7 +11963,7 @@
       </p:sp>
       <p:sp>
         <p:nvSpPr>
-          <p:cNvPr id="260" name="Google Shape;260;p11"/>
+          <p:cNvPr id="262" name="Google Shape;262;p11"/>
           <p:cNvSpPr txBox="1"/>
           <p:nvPr/>
         </p:nvSpPr>
@@ -11885,7 +12100,7 @@
       </p:sp>
       <p:sp>
         <p:nvSpPr>
-          <p:cNvPr id="261" name="Google Shape;261;p11"/>
+          <p:cNvPr id="263" name="Google Shape;263;p11"/>
           <p:cNvSpPr/>
           <p:nvPr/>
         </p:nvSpPr>
@@ -11936,7 +12151,7 @@
       </p:sp>
       <p:sp>
         <p:nvSpPr>
-          <p:cNvPr id="262" name="Google Shape;262;p11"/>
+          <p:cNvPr id="264" name="Google Shape;264;p11"/>
           <p:cNvSpPr/>
           <p:nvPr/>
         </p:nvSpPr>
@@ -11985,7 +12200,7 @@
       </p:sp>
       <p:pic>
         <p:nvPicPr>
-          <p:cNvPr descr="preencoded.png" id="263" name="Google Shape;263;p11"/>
+          <p:cNvPr descr="preencoded.png" id="265" name="Google Shape;265;p11"/>
           <p:cNvPicPr preferRelativeResize="0"/>
           <p:nvPr/>
         </p:nvPicPr>
@@ -12012,7 +12227,7 @@
       </p:pic>
       <p:sp>
         <p:nvSpPr>
-          <p:cNvPr id="264" name="Google Shape;264;p11"/>
+          <p:cNvPr id="266" name="Google Shape;266;p11"/>
           <p:cNvSpPr txBox="1"/>
           <p:nvPr/>
         </p:nvSpPr>
@@ -12093,7 +12308,7 @@
     </p:bg>
     <p:spTree>
       <p:nvGrpSpPr>
-        <p:cNvPr id="269" name="Shape 269"/>
+        <p:cNvPr id="271" name="Shape 271"/>
         <p:cNvGrpSpPr/>
         <p:nvPr/>
       </p:nvGrpSpPr>
@@ -12107,7 +12322,7 @@
       </p:grpSpPr>
       <p:sp>
         <p:nvSpPr>
-          <p:cNvPr id="270" name="Google Shape;270;p12"/>
+          <p:cNvPr id="272" name="Google Shape;272;p12"/>
           <p:cNvSpPr txBox="1"/>
           <p:nvPr/>
         </p:nvSpPr>
@@ -12170,7 +12385,7 @@
       </p:sp>
       <p:cxnSp>
         <p:nvCxnSpPr>
-          <p:cNvPr id="271" name="Google Shape;271;p12"/>
+          <p:cNvPr id="273" name="Google Shape;273;p12"/>
           <p:cNvCxnSpPr/>
           <p:nvPr/>
         </p:nvCxnSpPr>
@@ -12196,7 +12411,7 @@
       </p:cxnSp>
       <p:cxnSp>
         <p:nvCxnSpPr>
-          <p:cNvPr id="272" name="Google Shape;272;p12"/>
+          <p:cNvPr id="274" name="Google Shape;274;p12"/>
           <p:cNvCxnSpPr/>
           <p:nvPr/>
         </p:nvCxnSpPr>
@@ -12222,7 +12437,7 @@
       </p:cxnSp>
       <p:sp>
         <p:nvSpPr>
-          <p:cNvPr id="273" name="Google Shape;273;p12"/>
+          <p:cNvPr id="275" name="Google Shape;275;p12"/>
           <p:cNvSpPr/>
           <p:nvPr/>
         </p:nvSpPr>
@@ -12295,7 +12510,7 @@
       </p:sp>
       <p:sp>
         <p:nvSpPr>
-          <p:cNvPr id="274" name="Google Shape;274;p12"/>
+          <p:cNvPr id="276" name="Google Shape;276;p12"/>
           <p:cNvSpPr/>
           <p:nvPr/>
         </p:nvSpPr>
@@ -12368,7 +12583,7 @@
       </p:sp>
       <p:cxnSp>
         <p:nvCxnSpPr>
-          <p:cNvPr id="275" name="Google Shape;275;p12"/>
+          <p:cNvPr id="277" name="Google Shape;277;p12"/>
           <p:cNvCxnSpPr/>
           <p:nvPr/>
         </p:nvCxnSpPr>
@@ -12394,7 +12609,7 @@
       </p:cxnSp>
       <p:cxnSp>
         <p:nvCxnSpPr>
-          <p:cNvPr id="276" name="Google Shape;276;p12"/>
+          <p:cNvPr id="278" name="Google Shape;278;p12"/>
           <p:cNvCxnSpPr/>
           <p:nvPr/>
         </p:nvCxnSpPr>
@@ -12420,7 +12635,7 @@
       </p:cxnSp>
       <p:sp>
         <p:nvSpPr>
-          <p:cNvPr id="277" name="Google Shape;277;p12"/>
+          <p:cNvPr id="279" name="Google Shape;279;p12"/>
           <p:cNvSpPr/>
           <p:nvPr/>
         </p:nvSpPr>
@@ -12493,7 +12708,7 @@
       </p:sp>
       <p:sp>
         <p:nvSpPr>
-          <p:cNvPr id="278" name="Google Shape;278;p12"/>
+          <p:cNvPr id="280" name="Google Shape;280;p12"/>
           <p:cNvSpPr/>
           <p:nvPr/>
         </p:nvSpPr>
@@ -12566,7 +12781,7 @@
       </p:sp>
       <p:cxnSp>
         <p:nvCxnSpPr>
-          <p:cNvPr id="279" name="Google Shape;279;p12"/>
+          <p:cNvPr id="281" name="Google Shape;281;p12"/>
           <p:cNvCxnSpPr/>
           <p:nvPr/>
         </p:nvCxnSpPr>
@@ -12592,7 +12807,7 @@
       </p:cxnSp>
       <p:cxnSp>
         <p:nvCxnSpPr>
-          <p:cNvPr id="280" name="Google Shape;280;p12"/>
+          <p:cNvPr id="282" name="Google Shape;282;p12"/>
           <p:cNvCxnSpPr/>
           <p:nvPr/>
         </p:nvCxnSpPr>
@@ -12618,7 +12833,7 @@
       </p:cxnSp>
       <p:sp>
         <p:nvSpPr>
-          <p:cNvPr id="281" name="Google Shape;281;p12"/>
+          <p:cNvPr id="283" name="Google Shape;283;p12"/>
           <p:cNvSpPr/>
           <p:nvPr/>
         </p:nvSpPr>
@@ -12691,7 +12906,7 @@
       </p:sp>
       <p:sp>
         <p:nvSpPr>
-          <p:cNvPr id="282" name="Google Shape;282;p12"/>
+          <p:cNvPr id="284" name="Google Shape;284;p12"/>
           <p:cNvSpPr/>
           <p:nvPr/>
         </p:nvSpPr>
@@ -12764,7 +12979,7 @@
       </p:sp>
       <p:sp>
         <p:nvSpPr>
-          <p:cNvPr id="283" name="Google Shape;283;p12"/>
+          <p:cNvPr id="285" name="Google Shape;285;p12"/>
           <p:cNvSpPr/>
           <p:nvPr/>
         </p:nvSpPr>
@@ -12813,7 +13028,7 @@
       </p:sp>
       <p:sp>
         <p:nvSpPr>
-          <p:cNvPr id="284" name="Google Shape;284;p12"/>
+          <p:cNvPr id="286" name="Google Shape;286;p12"/>
           <p:cNvSpPr txBox="1"/>
           <p:nvPr/>
         </p:nvSpPr>
@@ -12913,7 +13128,7 @@
       </p:sp>
       <p:sp>
         <p:nvSpPr>
-          <p:cNvPr id="285" name="Google Shape;285;p12"/>
+          <p:cNvPr id="287" name="Google Shape;287;p12"/>
           <p:cNvSpPr txBox="1"/>
           <p:nvPr/>
         </p:nvSpPr>
@@ -12994,7 +13209,7 @@
     </p:bg>
     <p:spTree>
       <p:nvGrpSpPr>
-        <p:cNvPr id="290" name="Shape 290"/>
+        <p:cNvPr id="292" name="Shape 292"/>
         <p:cNvGrpSpPr/>
         <p:nvPr/>
       </p:nvGrpSpPr>
@@ -13008,7 +13223,7 @@
       </p:grpSpPr>
       <p:sp>
         <p:nvSpPr>
-          <p:cNvPr id="291" name="Google Shape;291;p13"/>
+          <p:cNvPr id="293" name="Google Shape;293;p13"/>
           <p:cNvSpPr txBox="1"/>
           <p:nvPr/>
         </p:nvSpPr>
@@ -13071,7 +13286,7 @@
       </p:sp>
       <p:cxnSp>
         <p:nvCxnSpPr>
-          <p:cNvPr id="292" name="Google Shape;292;p13"/>
+          <p:cNvPr id="294" name="Google Shape;294;p13"/>
           <p:cNvCxnSpPr/>
           <p:nvPr/>
         </p:nvCxnSpPr>
@@ -13097,7 +13312,7 @@
       </p:cxnSp>
       <p:sp>
         <p:nvSpPr>
-          <p:cNvPr id="293" name="Google Shape;293;p13"/>
+          <p:cNvPr id="295" name="Google Shape;295;p13"/>
           <p:cNvSpPr/>
           <p:nvPr/>
         </p:nvSpPr>
@@ -13146,7 +13361,7 @@
       </p:sp>
       <p:pic>
         <p:nvPicPr>
-          <p:cNvPr descr="preencoded.png" id="294" name="Google Shape;294;p13"/>
+          <p:cNvPr descr="preencoded.png" id="296" name="Google Shape;296;p13"/>
           <p:cNvPicPr preferRelativeResize="0"/>
           <p:nvPr/>
         </p:nvPicPr>
@@ -13173,7 +13388,7 @@
       </p:pic>
       <p:sp>
         <p:nvSpPr>
-          <p:cNvPr id="295" name="Google Shape;295;p13"/>
+          <p:cNvPr id="297" name="Google Shape;297;p13"/>
           <p:cNvSpPr txBox="1"/>
           <p:nvPr/>
         </p:nvSpPr>
@@ -13236,7 +13451,7 @@
       </p:sp>
       <p:sp>
         <p:nvSpPr>
-          <p:cNvPr id="296" name="Google Shape;296;p13"/>
+          <p:cNvPr id="298" name="Google Shape;298;p13"/>
           <p:cNvSpPr txBox="1"/>
           <p:nvPr/>
         </p:nvSpPr>
@@ -13299,7 +13514,7 @@
       </p:sp>
       <p:sp>
         <p:nvSpPr>
-          <p:cNvPr id="297" name="Google Shape;297;p13"/>
+          <p:cNvPr id="299" name="Google Shape;299;p13"/>
           <p:cNvSpPr/>
           <p:nvPr/>
         </p:nvSpPr>
@@ -13348,7 +13563,7 @@
       </p:sp>
       <p:pic>
         <p:nvPicPr>
-          <p:cNvPr descr="preencoded.png" id="298" name="Google Shape;298;p13"/>
+          <p:cNvPr descr="preencoded.png" id="300" name="Google Shape;300;p13"/>
           <p:cNvPicPr preferRelativeResize="0"/>
           <p:nvPr/>
         </p:nvPicPr>
@@ -13375,7 +13590,7 @@
       </p:pic>
       <p:sp>
         <p:nvSpPr>
-          <p:cNvPr id="299" name="Google Shape;299;p13"/>
+          <p:cNvPr id="301" name="Google Shape;301;p13"/>
           <p:cNvSpPr txBox="1"/>
           <p:nvPr/>
         </p:nvSpPr>
@@ -13438,7 +13653,7 @@
       </p:sp>
       <p:sp>
         <p:nvSpPr>
-          <p:cNvPr id="300" name="Google Shape;300;p13"/>
+          <p:cNvPr id="302" name="Google Shape;302;p13"/>
           <p:cNvSpPr txBox="1"/>
           <p:nvPr/>
         </p:nvSpPr>
@@ -13501,7 +13716,7 @@
       </p:sp>
       <p:sp>
         <p:nvSpPr>
-          <p:cNvPr id="301" name="Google Shape;301;p13"/>
+          <p:cNvPr id="303" name="Google Shape;303;p13"/>
           <p:cNvSpPr/>
           <p:nvPr/>
         </p:nvSpPr>
@@ -13550,7 +13765,7 @@
       </p:sp>
       <p:pic>
         <p:nvPicPr>
-          <p:cNvPr descr="preencoded.png" id="302" name="Google Shape;302;p13"/>
+          <p:cNvPr descr="preencoded.png" id="304" name="Google Shape;304;p13"/>
           <p:cNvPicPr preferRelativeResize="0"/>
           <p:nvPr/>
         </p:nvPicPr>
@@ -13577,7 +13792,7 @@
       </p:pic>
       <p:sp>
         <p:nvSpPr>
-          <p:cNvPr id="303" name="Google Shape;303;p13"/>
+          <p:cNvPr id="305" name="Google Shape;305;p13"/>
           <p:cNvSpPr txBox="1"/>
           <p:nvPr/>
         </p:nvSpPr>
@@ -13640,7 +13855,7 @@
       </p:sp>
       <p:sp>
         <p:nvSpPr>
-          <p:cNvPr id="304" name="Google Shape;304;p13"/>
+          <p:cNvPr id="306" name="Google Shape;306;p13"/>
           <p:cNvSpPr txBox="1"/>
           <p:nvPr/>
         </p:nvSpPr>
@@ -13703,14 +13918,298 @@
       </p:sp>
       <p:sp>
         <p:nvSpPr>
-          <p:cNvPr id="305" name="Google Shape;305;p13"/>
+          <p:cNvPr id="307" name="Google Shape;307;p13"/>
+          <p:cNvSpPr txBox="1"/>
+          <p:nvPr/>
+        </p:nvSpPr>
+        <p:spPr>
+          <a:xfrm>
+            <a:off x="548700" y="3994448"/>
+            <a:ext cx="8046600" cy="987000"/>
+          </a:xfrm>
+          <a:prstGeom prst="rect">
+            <a:avLst/>
+          </a:prstGeom>
+          <a:noFill/>
+          <a:ln>
+            <a:noFill/>
+          </a:ln>
+        </p:spPr>
+        <p:txBody>
+          <a:bodyPr anchorCtr="0" anchor="t" bIns="0" lIns="0" spcFirstLastPara="1" rIns="0" wrap="square" tIns="0">
+            <a:noAutofit/>
+          </a:bodyPr>
+          <a:lstStyle/>
+          <a:p>
+            <a:pPr indent="0" lvl="0" marL="0" marR="0" rtl="0" algn="l">
+              <a:spcBef>
+                <a:spcPts val="0"/>
+              </a:spcBef>
+              <a:spcAft>
+                <a:spcPts val="0"/>
+              </a:spcAft>
+              <a:buClr>
+                <a:srgbClr val="6B7280"/>
+              </a:buClr>
+              <a:buSzPts val="1000"/>
+              <a:buFont typeface="Arial"/>
+              <a:buNone/>
+            </a:pPr>
+            <a:r>
+              <a:rPr b="0" i="0" lang="en-US" sz="1600" u="none" cap="none" strike="noStrike">
+                <a:solidFill>
+                  <a:srgbClr val="6B7280"/>
+                </a:solidFill>
+                <a:latin typeface="Arial"/>
+                <a:ea typeface="Arial"/>
+                <a:cs typeface="Arial"/>
+                <a:sym typeface="Arial"/>
+              </a:rPr>
+              <a:t>Codice open source: </a:t>
+            </a:r>
+            <a:r>
+              <a:rPr lang="en-US" sz="1700" u="sng">
+                <a:solidFill>
+                  <a:srgbClr val="1155CC"/>
+                </a:solidFill>
+                <a:hlinkClick r:id="rId6">
+                  <a:extLst>
+                    <a:ext uri="{A12FA001-AC4F-418D-AE19-62706E023703}">
+                      <ahyp:hlinkClr val="tx"/>
+                    </a:ext>
+                  </a:extLst>
+                </a:hlinkClick>
+              </a:rPr>
+              <a:t>https://github.com/ricardoConsulenze/sportello-amico</a:t>
+            </a:r>
+            <a:r>
+              <a:rPr lang="en-US" sz="1700" u="sng">
+                <a:solidFill>
+                  <a:srgbClr val="1155CC"/>
+                </a:solidFill>
+              </a:rPr>
+              <a:t> </a:t>
+            </a:r>
+            <a:endParaRPr sz="1700" u="sng">
+              <a:solidFill>
+                <a:srgbClr val="1155CC"/>
+              </a:solidFill>
+            </a:endParaRPr>
+          </a:p>
+          <a:p>
+            <a:pPr indent="0" lvl="0" marL="0" marR="0" rtl="0" algn="l">
+              <a:spcBef>
+                <a:spcPts val="0"/>
+              </a:spcBef>
+              <a:spcAft>
+                <a:spcPts val="0"/>
+              </a:spcAft>
+              <a:buClr>
+                <a:srgbClr val="6B7280"/>
+              </a:buClr>
+              <a:buSzPts val="1000"/>
+              <a:buFont typeface="Arial"/>
+              <a:buNone/>
+            </a:pPr>
+            <a:r>
+              <a:rPr lang="en-US" sz="1600">
+                <a:solidFill>
+                  <a:srgbClr val="6B7280"/>
+                </a:solidFill>
+              </a:rPr>
+              <a:t>Prototipo :</a:t>
+            </a:r>
+            <a:r>
+              <a:rPr lang="en-US" sz="1700">
+                <a:solidFill>
+                  <a:schemeClr val="dk1"/>
+                </a:solidFill>
+              </a:rPr>
+              <a:t> </a:t>
+            </a:r>
+            <a:r>
+              <a:rPr lang="en-US" sz="1700" u="sng">
+                <a:solidFill>
+                  <a:srgbClr val="1155CC"/>
+                </a:solidFill>
+              </a:rPr>
+              <a:t>https://sportello-amico-main.vercel.app/</a:t>
+            </a:r>
+            <a:endParaRPr sz="1700">
+              <a:solidFill>
+                <a:schemeClr val="dk1"/>
+              </a:solidFill>
+            </a:endParaRPr>
+          </a:p>
+          <a:p>
+            <a:pPr indent="0" lvl="0" marL="0" marR="0" rtl="0" algn="l">
+              <a:spcBef>
+                <a:spcPts val="0"/>
+              </a:spcBef>
+              <a:spcAft>
+                <a:spcPts val="0"/>
+              </a:spcAft>
+              <a:buClr>
+                <a:srgbClr val="6B7280"/>
+              </a:buClr>
+              <a:buSzPts val="1000"/>
+              <a:buFont typeface="Arial"/>
+              <a:buNone/>
+            </a:pPr>
+            <a:r>
+              <a:t/>
+            </a:r>
+            <a:endParaRPr sz="1100">
+              <a:solidFill>
+                <a:schemeClr val="dk1"/>
+              </a:solidFill>
+            </a:endParaRPr>
+          </a:p>
+        </p:txBody>
+      </p:sp>
+      <p:sp>
+        <p:nvSpPr>
+          <p:cNvPr id="308" name="Google Shape;308;p13"/>
+          <p:cNvSpPr txBox="1"/>
+          <p:nvPr/>
+        </p:nvSpPr>
+        <p:spPr>
+          <a:xfrm>
+            <a:off x="5746000" y="3047300"/>
+            <a:ext cx="3000000" cy="615600"/>
+          </a:xfrm>
+          <a:prstGeom prst="rect">
+            <a:avLst/>
+          </a:prstGeom>
+          <a:noFill/>
+          <a:ln>
+            <a:noFill/>
+          </a:ln>
+        </p:spPr>
+        <p:txBody>
+          <a:bodyPr anchorCtr="0" anchor="t" bIns="91425" lIns="91425" spcFirstLastPara="1" rIns="91425" wrap="square" tIns="91425">
+            <a:spAutoFit/>
+          </a:bodyPr>
+          <a:lstStyle/>
+          <a:p>
+            <a:pPr indent="0" lvl="0" marL="0" rtl="0" algn="l">
+              <a:spcBef>
+                <a:spcPts val="0"/>
+              </a:spcBef>
+              <a:spcAft>
+                <a:spcPts val="0"/>
+              </a:spcAft>
+              <a:buNone/>
+            </a:pPr>
+            <a:r>
+              <a:rPr lang="en-US"/>
+              <a:t>https://sportello-amico-main.vercel.app/</a:t>
+            </a:r>
+            <a:endParaRPr/>
+          </a:p>
+        </p:txBody>
+      </p:sp>
+    </p:spTree>
+  </p:cSld>
+  <p:clrMapOvr>
+    <a:masterClrMapping/>
+  </p:clrMapOvr>
+</p:sld>
+</file>
+
+<file path=ppt/slides/slide17.xml><?xml version="1.0" encoding="utf-8"?>
+<p:sld xmlns:a="http://schemas.openxmlformats.org/drawingml/2006/main" xmlns:r="http://schemas.openxmlformats.org/officeDocument/2006/relationships" xmlns:mc="http://schemas.openxmlformats.org/markup-compatibility/2006" xmlns:mv="urn:schemas-microsoft-com:mac:vml" xmlns:p="http://schemas.openxmlformats.org/presentationml/2006/main" xmlns:c="http://schemas.openxmlformats.org/drawingml/2006/chart" xmlns:dgm="http://schemas.openxmlformats.org/drawingml/2006/diagram" xmlns:o="urn:schemas-microsoft-com:office:office" xmlns:v="urn:schemas-microsoft-com:vml" xmlns:pvml="urn:schemas-microsoft-com:office:powerpoint" xmlns:com="http://schemas.openxmlformats.org/drawingml/2006/compatibility" xmlns:p14="http://schemas.microsoft.com/office/powerpoint/2010/main" xmlns:p15="http://schemas.microsoft.com/office/powerpoint/2012/main" xmlns:ahyp="http://schemas.microsoft.com/office/drawing/2018/hyperlinkcolor">
+  <p:cSld>
+    <p:bg>
+      <p:bgPr>
+        <a:solidFill>
+          <a:srgbClr val="F6ECD8"/>
+        </a:solidFill>
+      </p:bgPr>
+    </p:bg>
+    <p:spTree>
+      <p:nvGrpSpPr>
+        <p:cNvPr id="313" name="Shape 313"/>
+        <p:cNvGrpSpPr/>
+        <p:nvPr/>
+      </p:nvGrpSpPr>
+      <p:grpSpPr>
+        <a:xfrm>
+          <a:off x="0" y="0"/>
+          <a:ext cx="0" cy="0"/>
+          <a:chOff x="0" y="0"/>
+          <a:chExt cx="0" cy="0"/>
+        </a:xfrm>
+      </p:grpSpPr>
+      <p:sp>
+        <p:nvSpPr>
+          <p:cNvPr id="314" name="Google Shape;314;h1c30e251418f18d3_5_0"/>
+          <p:cNvSpPr txBox="1"/>
+          <p:nvPr/>
+        </p:nvSpPr>
+        <p:spPr>
+          <a:xfrm>
+            <a:off x="548640" y="384048"/>
+            <a:ext cx="8046600" cy="567000"/>
+          </a:xfrm>
+          <a:prstGeom prst="rect">
+            <a:avLst/>
+          </a:prstGeom>
+          <a:noFill/>
+          <a:ln>
+            <a:noFill/>
+          </a:ln>
+        </p:spPr>
+        <p:txBody>
+          <a:bodyPr anchorCtr="0" anchor="t" bIns="0" lIns="0" spcFirstLastPara="1" rIns="0" wrap="square" tIns="0">
+            <a:noAutofit/>
+          </a:bodyPr>
+          <a:lstStyle/>
+          <a:p>
+            <a:pPr indent="0" lvl="0" marL="0" marR="0" rtl="0" algn="l">
+              <a:spcBef>
+                <a:spcPts val="0"/>
+              </a:spcBef>
+              <a:spcAft>
+                <a:spcPts val="0"/>
+              </a:spcAft>
+              <a:buClr>
+                <a:srgbClr val="15171A"/>
+              </a:buClr>
+              <a:buSzPts val="3000"/>
+              <a:buFont typeface="Arial"/>
+              <a:buNone/>
+            </a:pPr>
+            <a:r>
+              <a:rPr b="1" lang="en-US" sz="3000">
+                <a:solidFill>
+                  <a:srgbClr val="15171A"/>
+                </a:solidFill>
+              </a:rPr>
+              <a:t>Il team </a:t>
+            </a:r>
+            <a:endParaRPr b="0" i="0" sz="3000" u="none" cap="none" strike="noStrike">
+              <a:solidFill>
+                <a:schemeClr val="dk1"/>
+              </a:solidFill>
+              <a:latin typeface="Calibri"/>
+              <a:ea typeface="Calibri"/>
+              <a:cs typeface="Calibri"/>
+              <a:sym typeface="Calibri"/>
+            </a:endParaRPr>
+          </a:p>
+        </p:txBody>
+      </p:sp>
+      <p:sp>
+        <p:nvSpPr>
+          <p:cNvPr id="315" name="Google Shape;315;h1c30e251418f18d3_5_0"/>
           <p:cNvSpPr/>
           <p:nvPr/>
         </p:nvSpPr>
         <p:spPr>
           <a:xfrm>
-            <a:off x="548640" y="3703320"/>
-            <a:ext cx="8046720" cy="868680"/>
+            <a:off x="548640" y="4023918"/>
+            <a:ext cx="8046600" cy="868800"/>
           </a:xfrm>
           <a:prstGeom prst="roundRect">
             <a:avLst>
@@ -13754,14 +14253,14 @@
       </p:sp>
       <p:sp>
         <p:nvSpPr>
-          <p:cNvPr id="306" name="Google Shape;306;p13"/>
+          <p:cNvPr id="316" name="Google Shape;316;h1c30e251418f18d3_5_0"/>
           <p:cNvSpPr txBox="1"/>
           <p:nvPr/>
         </p:nvSpPr>
         <p:spPr>
           <a:xfrm>
-            <a:off x="822960" y="3703320"/>
-            <a:ext cx="7498080" cy="868680"/>
+            <a:off x="822960" y="4023918"/>
+            <a:ext cx="7498200" cy="868800"/>
           </a:xfrm>
           <a:prstGeom prst="rect">
             <a:avLst/>
@@ -13817,14 +14316,14 @@
       </p:sp>
       <p:sp>
         <p:nvSpPr>
-          <p:cNvPr id="307" name="Google Shape;307;p13"/>
+          <p:cNvPr id="317" name="Google Shape;317;h1c30e251418f18d3_5_0"/>
           <p:cNvSpPr txBox="1"/>
           <p:nvPr/>
         </p:nvSpPr>
         <p:spPr>
           <a:xfrm>
-            <a:off x="548640" y="4736592"/>
-            <a:ext cx="8046720" cy="256032"/>
+            <a:off x="711250" y="2346637"/>
+            <a:ext cx="4023300" cy="1795800"/>
           </a:xfrm>
           <a:prstGeom prst="rect">
             <a:avLst/>
@@ -13848,56 +14347,183 @@
                 <a:spcPts val="0"/>
               </a:spcAft>
               <a:buClr>
-                <a:srgbClr val="6B7280"/>
+                <a:srgbClr val="15171A"/>
               </a:buClr>
-              <a:buSzPts val="1000"/>
+              <a:buSzPts val="1800"/>
               <a:buFont typeface="Arial"/>
               <a:buNone/>
             </a:pPr>
             <a:r>
-              <a:rPr b="0" i="0" lang="en-US" sz="1000" u="none" cap="none" strike="noStrike">
-                <a:solidFill>
-                  <a:srgbClr val="6B7280"/>
-                </a:solidFill>
-                <a:latin typeface="Arial"/>
-                <a:ea typeface="Arial"/>
-                <a:cs typeface="Arial"/>
-                <a:sym typeface="Arial"/>
+              <a:rPr b="1" lang="en-US" sz="1800" u="sng">
+                <a:solidFill>
+                  <a:schemeClr val="hlink"/>
+                </a:solidFill>
+                <a:hlinkClick r:id="rId3"/>
               </a:rPr>
-              <a:t>Codice open source: </a:t>
-            </a:r>
-            <a:r>
-              <a:rPr lang="en-US" sz="1100" u="sng">
-                <a:solidFill>
-                  <a:srgbClr val="1155CC"/>
-                </a:solidFill>
-                <a:hlinkClick r:id="rId6">
-                  <a:extLst>
-                    <a:ext uri="{A12FA001-AC4F-418D-AE19-62706E023703}">
-                      <ahyp:hlinkClr val="tx"/>
-                    </a:ext>
-                  </a:extLst>
-                </a:hlinkClick>
+              <a:t>Francesca Sampietro</a:t>
+            </a:r>
+            <a:endParaRPr b="1" sz="1800">
+              <a:solidFill>
+                <a:srgbClr val="15171A"/>
+              </a:solidFill>
+            </a:endParaRPr>
+          </a:p>
+          <a:p>
+            <a:pPr indent="0" lvl="0" marL="0" marR="0" rtl="0" algn="l">
+              <a:spcBef>
+                <a:spcPts val="0"/>
+              </a:spcBef>
+              <a:spcAft>
+                <a:spcPts val="0"/>
+              </a:spcAft>
+              <a:buClr>
+                <a:srgbClr val="15171A"/>
+              </a:buClr>
+              <a:buSzPts val="1800"/>
+              <a:buFont typeface="Arial"/>
+              <a:buNone/>
+            </a:pPr>
+            <a:r>
+              <a:rPr b="1" lang="en-US" sz="1800" u="sng">
+                <a:solidFill>
+                  <a:schemeClr val="hlink"/>
+                </a:solidFill>
+                <a:hlinkClick r:id="rId4"/>
               </a:rPr>
-              <a:t>https://github.com/ricardoConsulenze/sportello-amico</a:t>
-            </a:r>
-            <a:r>
-              <a:rPr lang="en-US" sz="1100">
-                <a:solidFill>
-                  <a:schemeClr val="dk1"/>
-                </a:solidFill>
+              <a:t>Iuliia Vorobiova</a:t>
+            </a:r>
+            <a:endParaRPr b="1" sz="1800">
+              <a:solidFill>
+                <a:srgbClr val="15171A"/>
+              </a:solidFill>
+            </a:endParaRPr>
+          </a:p>
+          <a:p>
+            <a:pPr indent="0" lvl="0" marL="0" marR="0" rtl="0" algn="l">
+              <a:spcBef>
+                <a:spcPts val="0"/>
+              </a:spcBef>
+              <a:spcAft>
+                <a:spcPts val="0"/>
+              </a:spcAft>
+              <a:buClr>
+                <a:srgbClr val="15171A"/>
+              </a:buClr>
+              <a:buSzPts val="1800"/>
+              <a:buFont typeface="Arial"/>
+              <a:buNone/>
+            </a:pPr>
+            <a:r>
+              <a:rPr b="1" lang="en-US" sz="1800" u="sng">
+                <a:solidFill>
+                  <a:schemeClr val="hlink"/>
+                </a:solidFill>
+                <a:hlinkClick r:id="rId5"/>
               </a:rPr>
-              <a:t> </a:t>
-            </a:r>
-            <a:endParaRPr b="0" i="0" sz="1000" u="none" cap="none" strike="noStrike">
+              <a:t>Ricardo Matamoros</a:t>
+            </a:r>
+            <a:br>
+              <a:rPr b="1" lang="en-US" sz="1800">
+                <a:solidFill>
+                  <a:srgbClr val="15171A"/>
+                </a:solidFill>
+              </a:rPr>
+            </a:br>
+            <a:r>
+              <a:rPr b="1" lang="en-US" sz="1800">
+                <a:solidFill>
+                  <a:srgbClr val="15171A"/>
+                </a:solidFill>
+              </a:rPr>
+              <a:t>Reda Charf</a:t>
+            </a:r>
+            <a:br>
+              <a:rPr b="1" lang="en-US" sz="1800">
+                <a:solidFill>
+                  <a:srgbClr val="15171A"/>
+                </a:solidFill>
+              </a:rPr>
+            </a:br>
+            <a:r>
+              <a:rPr b="1" lang="en-US" sz="1800" u="sng">
+                <a:solidFill>
+                  <a:schemeClr val="hlink"/>
+                </a:solidFill>
+                <a:hlinkClick r:id="rId6"/>
+              </a:rPr>
+              <a:t>Massimiliano Mancini Tortora</a:t>
+            </a:r>
+            <a:endParaRPr b="1" sz="1800">
               <a:solidFill>
-                <a:schemeClr val="dk1"/>
+                <a:srgbClr val="15171A"/>
               </a:solidFill>
-              <a:latin typeface="Calibri"/>
-              <a:ea typeface="Calibri"/>
-              <a:cs typeface="Calibri"/>
-              <a:sym typeface="Calibri"/>
             </a:endParaRPr>
+          </a:p>
+          <a:p>
+            <a:pPr indent="0" lvl="0" marL="0" marR="0" rtl="0" algn="l">
+              <a:spcBef>
+                <a:spcPts val="0"/>
+              </a:spcBef>
+              <a:spcAft>
+                <a:spcPts val="0"/>
+              </a:spcAft>
+              <a:buClr>
+                <a:srgbClr val="15171A"/>
+              </a:buClr>
+              <a:buSzPts val="1800"/>
+              <a:buFont typeface="Arial"/>
+              <a:buNone/>
+            </a:pPr>
+            <a:r>
+              <a:t/>
+            </a:r>
+            <a:endParaRPr b="1" sz="1800">
+              <a:solidFill>
+                <a:srgbClr val="15171A"/>
+              </a:solidFill>
+            </a:endParaRPr>
+          </a:p>
+        </p:txBody>
+      </p:sp>
+      <p:sp>
+        <p:nvSpPr>
+          <p:cNvPr id="318" name="Google Shape;318;h1c30e251418f18d3_5_0"/>
+          <p:cNvSpPr txBox="1"/>
+          <p:nvPr/>
+        </p:nvSpPr>
+        <p:spPr>
+          <a:xfrm>
+            <a:off x="2369000" y="650950"/>
+            <a:ext cx="5260800" cy="1003200"/>
+          </a:xfrm>
+          <a:prstGeom prst="rect">
+            <a:avLst/>
+          </a:prstGeom>
+          <a:noFill/>
+          <a:ln>
+            <a:noFill/>
+          </a:ln>
+        </p:spPr>
+        <p:txBody>
+          <a:bodyPr anchorCtr="0" anchor="t" bIns="91425" lIns="91425" spcFirstLastPara="1" rIns="91425" wrap="square" tIns="91425">
+            <a:noAutofit/>
+          </a:bodyPr>
+          <a:lstStyle/>
+          <a:p>
+            <a:pPr indent="0" lvl="0" marL="0" rtl="0" algn="l">
+              <a:spcBef>
+                <a:spcPts val="0"/>
+              </a:spcBef>
+              <a:spcAft>
+                <a:spcPts val="0"/>
+              </a:spcAft>
+              <a:buNone/>
+            </a:pPr>
+            <a:r>
+              <a:rPr b="1" lang="en-US" sz="4200"/>
+              <a:t>GRAZIE PER L’ATTENZIONE!</a:t>
+            </a:r>
+            <a:endParaRPr b="1" sz="4200"/>
           </a:p>
         </p:txBody>
       </p:sp>
@@ -13921,7 +14547,7 @@
     </p:bg>
     <p:spTree>
       <p:nvGrpSpPr>
-        <p:cNvPr id="26" name="Shape 26"/>
+        <p:cNvPr id="28" name="Shape 28"/>
         <p:cNvGrpSpPr/>
         <p:nvPr/>
       </p:nvGrpSpPr>
@@ -13935,7 +14561,7 @@
       </p:grpSpPr>
       <p:sp>
         <p:nvSpPr>
-          <p:cNvPr id="27" name="Google Shape;27;p2"/>
+          <p:cNvPr id="29" name="Google Shape;29;p2"/>
           <p:cNvSpPr txBox="1"/>
           <p:nvPr/>
         </p:nvSpPr>
@@ -13998,7 +14624,7 @@
       </p:sp>
       <p:sp>
         <p:nvSpPr>
-          <p:cNvPr id="28" name="Google Shape;28;p2"/>
+          <p:cNvPr id="30" name="Google Shape;30;p2"/>
           <p:cNvSpPr txBox="1"/>
           <p:nvPr/>
         </p:nvSpPr>
@@ -14061,7 +14687,7 @@
       </p:sp>
       <p:sp>
         <p:nvSpPr>
-          <p:cNvPr id="29" name="Google Shape;29;p2"/>
+          <p:cNvPr id="31" name="Google Shape;31;p2"/>
           <p:cNvSpPr txBox="1"/>
           <p:nvPr/>
         </p:nvSpPr>
@@ -14124,7 +14750,7 @@
       </p:sp>
       <p:sp>
         <p:nvSpPr>
-          <p:cNvPr id="30" name="Google Shape;30;p2"/>
+          <p:cNvPr id="32" name="Google Shape;32;p2"/>
           <p:cNvSpPr txBox="1"/>
           <p:nvPr/>
         </p:nvSpPr>
@@ -14187,7 +14813,7 @@
       </p:sp>
       <p:sp>
         <p:nvSpPr>
-          <p:cNvPr id="31" name="Google Shape;31;p2"/>
+          <p:cNvPr id="33" name="Google Shape;33;p2"/>
           <p:cNvSpPr txBox="1"/>
           <p:nvPr/>
         </p:nvSpPr>
@@ -14250,7 +14876,7 @@
       </p:sp>
       <p:sp>
         <p:nvSpPr>
-          <p:cNvPr id="32" name="Google Shape;32;p2"/>
+          <p:cNvPr id="34" name="Google Shape;34;p2"/>
           <p:cNvSpPr txBox="1"/>
           <p:nvPr/>
         </p:nvSpPr>
@@ -14313,7 +14939,7 @@
       </p:sp>
       <p:sp>
         <p:nvSpPr>
-          <p:cNvPr id="33" name="Google Shape;33;p2"/>
+          <p:cNvPr id="35" name="Google Shape;35;p2"/>
           <p:cNvSpPr txBox="1"/>
           <p:nvPr/>
         </p:nvSpPr>
@@ -14376,7 +15002,7 @@
       </p:sp>
       <p:sp>
         <p:nvSpPr>
-          <p:cNvPr id="34" name="Google Shape;34;p2"/>
+          <p:cNvPr id="36" name="Google Shape;36;p2"/>
           <p:cNvSpPr txBox="1"/>
           <p:nvPr/>
         </p:nvSpPr>
@@ -14439,7 +15065,7 @@
       </p:sp>
       <p:sp>
         <p:nvSpPr>
-          <p:cNvPr id="35" name="Google Shape;35;p2"/>
+          <p:cNvPr id="37" name="Google Shape;37;p2"/>
           <p:cNvSpPr txBox="1"/>
           <p:nvPr/>
         </p:nvSpPr>
@@ -14502,7 +15128,7 @@
       </p:sp>
       <p:sp>
         <p:nvSpPr>
-          <p:cNvPr id="36" name="Google Shape;36;p2"/>
+          <p:cNvPr id="38" name="Google Shape;38;p2"/>
           <p:cNvSpPr txBox="1"/>
           <p:nvPr/>
         </p:nvSpPr>
@@ -14565,7 +15191,7 @@
       </p:sp>
       <p:sp>
         <p:nvSpPr>
-          <p:cNvPr id="37" name="Google Shape;37;p2"/>
+          <p:cNvPr id="39" name="Google Shape;39;p2"/>
           <p:cNvSpPr txBox="1"/>
           <p:nvPr/>
         </p:nvSpPr>
@@ -14628,7 +15254,7 @@
       </p:sp>
       <p:sp>
         <p:nvSpPr>
-          <p:cNvPr id="38" name="Google Shape;38;p2"/>
+          <p:cNvPr id="40" name="Google Shape;40;p2"/>
           <p:cNvSpPr txBox="1"/>
           <p:nvPr/>
         </p:nvSpPr>
@@ -14691,7 +15317,7 @@
       </p:sp>
       <p:sp>
         <p:nvSpPr>
-          <p:cNvPr id="39" name="Google Shape;39;p2"/>
+          <p:cNvPr id="41" name="Google Shape;41;p2"/>
           <p:cNvSpPr txBox="1"/>
           <p:nvPr/>
         </p:nvSpPr>
@@ -14754,7 +15380,7 @@
       </p:sp>
       <p:sp>
         <p:nvSpPr>
-          <p:cNvPr id="40" name="Google Shape;40;p2"/>
+          <p:cNvPr id="42" name="Google Shape;42;p2"/>
           <p:cNvSpPr txBox="1"/>
           <p:nvPr/>
         </p:nvSpPr>
@@ -14835,7 +15461,7 @@
     </p:bg>
     <p:spTree>
       <p:nvGrpSpPr>
-        <p:cNvPr id="45" name="Shape 45"/>
+        <p:cNvPr id="47" name="Shape 47"/>
         <p:cNvGrpSpPr/>
         <p:nvPr/>
       </p:nvGrpSpPr>
@@ -14849,7 +15475,7 @@
       </p:grpSpPr>
       <p:pic>
         <p:nvPicPr>
-          <p:cNvPr descr="preencoded.png" id="46" name="Google Shape;46;p3"/>
+          <p:cNvPr descr="preencoded.png" id="48" name="Google Shape;48;p3"/>
           <p:cNvPicPr preferRelativeResize="0"/>
           <p:nvPr/>
         </p:nvPicPr>
@@ -14883,7 +15509,7 @@
       </p:pic>
       <p:sp>
         <p:nvSpPr>
-          <p:cNvPr id="47" name="Google Shape;47;p3"/>
+          <p:cNvPr id="49" name="Google Shape;49;p3"/>
           <p:cNvSpPr/>
           <p:nvPr/>
         </p:nvSpPr>
@@ -14956,7 +15582,7 @@
       </p:sp>
       <p:sp>
         <p:nvSpPr>
-          <p:cNvPr id="48" name="Google Shape;48;p3"/>
+          <p:cNvPr id="50" name="Google Shape;50;p3"/>
           <p:cNvSpPr txBox="1"/>
           <p:nvPr/>
         </p:nvSpPr>
@@ -15019,7 +15645,7 @@
       </p:sp>
       <p:sp>
         <p:nvSpPr>
-          <p:cNvPr id="49" name="Google Shape;49;p3"/>
+          <p:cNvPr id="51" name="Google Shape;51;p3"/>
           <p:cNvSpPr txBox="1"/>
           <p:nvPr/>
         </p:nvSpPr>
@@ -15082,7 +15708,7 @@
       </p:sp>
       <p:sp>
         <p:nvSpPr>
-          <p:cNvPr id="50" name="Google Shape;50;p3"/>
+          <p:cNvPr id="52" name="Google Shape;52;p3"/>
           <p:cNvSpPr txBox="1"/>
           <p:nvPr/>
         </p:nvSpPr>
@@ -15163,7 +15789,7 @@
     </p:bg>
     <p:spTree>
       <p:nvGrpSpPr>
-        <p:cNvPr id="55" name="Shape 55"/>
+        <p:cNvPr id="57" name="Shape 57"/>
         <p:cNvGrpSpPr/>
         <p:nvPr/>
       </p:nvGrpSpPr>
@@ -15177,7 +15803,7 @@
       </p:grpSpPr>
       <p:sp>
         <p:nvSpPr>
-          <p:cNvPr id="56" name="Google Shape;56;p4"/>
+          <p:cNvPr id="58" name="Google Shape;58;p4"/>
           <p:cNvSpPr txBox="1"/>
           <p:nvPr/>
         </p:nvSpPr>
@@ -15240,7 +15866,7 @@
       </p:sp>
       <p:graphicFrame>
         <p:nvGraphicFramePr>
-          <p:cNvPr id="57" name="Google Shape;57;p4"/>
+          <p:cNvPr id="59" name="Google Shape;59;p4"/>
           <p:cNvGraphicFramePr/>
           <p:nvPr/>
         </p:nvGraphicFramePr>
@@ -15256,7 +15882,7 @@
       </p:graphicFrame>
       <p:sp>
         <p:nvSpPr>
-          <p:cNvPr id="58" name="Google Shape;58;p4"/>
+          <p:cNvPr id="60" name="Google Shape;60;p4"/>
           <p:cNvSpPr/>
           <p:nvPr/>
         </p:nvSpPr>
@@ -15307,7 +15933,7 @@
       </p:sp>
       <p:sp>
         <p:nvSpPr>
-          <p:cNvPr id="59" name="Google Shape;59;p4"/>
+          <p:cNvPr id="61" name="Google Shape;61;p4"/>
           <p:cNvSpPr txBox="1"/>
           <p:nvPr/>
         </p:nvSpPr>
@@ -15370,7 +15996,7 @@
       </p:sp>
       <p:sp>
         <p:nvSpPr>
-          <p:cNvPr id="60" name="Google Shape;60;p4"/>
+          <p:cNvPr id="62" name="Google Shape;62;p4"/>
           <p:cNvSpPr txBox="1"/>
           <p:nvPr/>
         </p:nvSpPr>
@@ -15433,7 +16059,7 @@
       </p:sp>
       <p:sp>
         <p:nvSpPr>
-          <p:cNvPr id="61" name="Google Shape;61;p4"/>
+          <p:cNvPr id="63" name="Google Shape;63;p4"/>
           <p:cNvSpPr txBox="1"/>
           <p:nvPr/>
         </p:nvSpPr>
@@ -15496,7 +16122,7 @@
       </p:sp>
       <p:sp>
         <p:nvSpPr>
-          <p:cNvPr id="62" name="Google Shape;62;p4"/>
+          <p:cNvPr id="64" name="Google Shape;64;p4"/>
           <p:cNvSpPr txBox="1"/>
           <p:nvPr/>
         </p:nvSpPr>
@@ -15559,7 +16185,7 @@
       </p:sp>
       <p:sp>
         <p:nvSpPr>
-          <p:cNvPr id="63" name="Google Shape;63;p4"/>
+          <p:cNvPr id="65" name="Google Shape;65;p4"/>
           <p:cNvSpPr txBox="1"/>
           <p:nvPr/>
         </p:nvSpPr>
@@ -15640,7 +16266,7 @@
     </p:bg>
     <p:spTree>
       <p:nvGrpSpPr>
-        <p:cNvPr id="68" name="Shape 68"/>
+        <p:cNvPr id="70" name="Shape 70"/>
         <p:cNvGrpSpPr/>
         <p:nvPr/>
       </p:nvGrpSpPr>
@@ -15654,7 +16280,7 @@
       </p:grpSpPr>
       <p:sp>
         <p:nvSpPr>
-          <p:cNvPr id="69" name="Google Shape;69;p5"/>
+          <p:cNvPr id="71" name="Google Shape;71;p5"/>
           <p:cNvSpPr txBox="1"/>
           <p:nvPr/>
         </p:nvSpPr>
@@ -15717,7 +16343,7 @@
       </p:sp>
       <p:sp>
         <p:nvSpPr>
-          <p:cNvPr id="70" name="Google Shape;70;p5"/>
+          <p:cNvPr id="72" name="Google Shape;72;p5"/>
           <p:cNvSpPr txBox="1"/>
           <p:nvPr/>
         </p:nvSpPr>
@@ -15780,7 +16406,7 @@
       </p:sp>
       <p:pic>
         <p:nvPicPr>
-          <p:cNvPr descr="preencoded.png" id="71" name="Google Shape;71;p5"/>
+          <p:cNvPr descr="preencoded.png" id="73" name="Google Shape;73;p5"/>
           <p:cNvPicPr preferRelativeResize="0"/>
           <p:nvPr/>
         </p:nvPicPr>
@@ -15814,7 +16440,7 @@
       </p:pic>
       <p:sp>
         <p:nvSpPr>
-          <p:cNvPr id="72" name="Google Shape;72;p5"/>
+          <p:cNvPr id="74" name="Google Shape;74;p5"/>
           <p:cNvSpPr/>
           <p:nvPr/>
         </p:nvSpPr>
@@ -15887,7 +16513,7 @@
       </p:sp>
       <p:sp>
         <p:nvSpPr>
-          <p:cNvPr id="73" name="Google Shape;73;p5"/>
+          <p:cNvPr id="75" name="Google Shape;75;p5"/>
           <p:cNvSpPr txBox="1"/>
           <p:nvPr/>
         </p:nvSpPr>
@@ -15950,7 +16576,7 @@
       </p:sp>
       <p:sp>
         <p:nvSpPr>
-          <p:cNvPr id="74" name="Google Shape;74;p5"/>
+          <p:cNvPr id="76" name="Google Shape;76;p5"/>
           <p:cNvSpPr/>
           <p:nvPr/>
         </p:nvSpPr>
@@ -16023,7 +16649,7 @@
       </p:sp>
       <p:sp>
         <p:nvSpPr>
-          <p:cNvPr id="75" name="Google Shape;75;p5"/>
+          <p:cNvPr id="77" name="Google Shape;77;p5"/>
           <p:cNvSpPr txBox="1"/>
           <p:nvPr/>
         </p:nvSpPr>
@@ -16086,7 +16712,7 @@
       </p:sp>
       <p:sp>
         <p:nvSpPr>
-          <p:cNvPr id="76" name="Google Shape;76;p5"/>
+          <p:cNvPr id="78" name="Google Shape;78;p5"/>
           <p:cNvSpPr/>
           <p:nvPr/>
         </p:nvSpPr>
@@ -16159,7 +16785,7 @@
       </p:sp>
       <p:sp>
         <p:nvSpPr>
-          <p:cNvPr id="77" name="Google Shape;77;p5"/>
+          <p:cNvPr id="79" name="Google Shape;79;p5"/>
           <p:cNvSpPr txBox="1"/>
           <p:nvPr/>
         </p:nvSpPr>
@@ -16240,7 +16866,7 @@
     </p:bg>
     <p:spTree>
       <p:nvGrpSpPr>
-        <p:cNvPr id="82" name="Shape 82"/>
+        <p:cNvPr id="84" name="Shape 84"/>
         <p:cNvGrpSpPr/>
         <p:nvPr/>
       </p:nvGrpSpPr>
@@ -16254,7 +16880,7 @@
       </p:grpSpPr>
       <p:sp>
         <p:nvSpPr>
-          <p:cNvPr id="83" name="Google Shape;83;h1c30e251418f18d3_1_10"/>
+          <p:cNvPr id="85" name="Google Shape;85;h1c30e251418f18d3_1_10"/>
           <p:cNvSpPr txBox="1"/>
           <p:nvPr/>
         </p:nvSpPr>
@@ -16313,7 +16939,7 @@
       </p:sp>
       <p:pic>
         <p:nvPicPr>
-          <p:cNvPr id="84" name="Google Shape;84;h1c30e251418f18d3_1_10" title="Screenshot 2026-10-03 at 15.22.25.png"/>
+          <p:cNvPr id="86" name="Google Shape;86;h1c30e251418f18d3_1_10" title="Screenshot 2026-10-03 at 15.22.25.png"/>
           <p:cNvPicPr preferRelativeResize="0"/>
           <p:nvPr/>
         </p:nvPicPr>
@@ -16358,7 +16984,7 @@
     </p:bg>
     <p:spTree>
       <p:nvGrpSpPr>
-        <p:cNvPr id="89" name="Shape 89"/>
+        <p:cNvPr id="91" name="Shape 91"/>
         <p:cNvGrpSpPr/>
         <p:nvPr/>
       </p:nvGrpSpPr>
@@ -16372,7 +16998,7 @@
       </p:grpSpPr>
       <p:sp>
         <p:nvSpPr>
-          <p:cNvPr id="90" name="Google Shape;90;h1c30e251418f18d3_2_2"/>
+          <p:cNvPr id="92" name="Google Shape;92;h1c30e251418f18d3_2_2"/>
           <p:cNvSpPr txBox="1"/>
           <p:nvPr/>
         </p:nvSpPr>
@@ -16431,7 +17057,7 @@
       </p:sp>
       <p:pic>
         <p:nvPicPr>
-          <p:cNvPr id="91" name="Google Shape;91;h1c30e251418f18d3_2_2" title="sportello-amico-demo.mp4">
+          <p:cNvPr id="93" name="Google Shape;93;h1c30e251418f18d3_2_2" title="sportello-amico-demo.mp4">
             <a:hlinkClick r:id="rId3"/>
           </p:cNvPr>
           <p:cNvPicPr preferRelativeResize="0"/>
@@ -16498,7 +17124,7 @@
                                           </p:stCondLst>
                                         </p:cTn>
                                         <p:tgtEl>
-                                          <p:spTgt spid="91"/>
+                                          <p:spTgt spid="93"/>
                                         </p:tgtEl>
                                         <p:attrNameLst>
                                           <p:attrName>style.visibility</p:attrName>
@@ -16512,7 +17138,7 @@
                                       <p:cBhvr>
                                         <p:cTn dur="1000"/>
                                         <p:tgtEl>
-                                          <p:spTgt spid="91"/>
+                                          <p:spTgt spid="93"/>
                                         </p:tgtEl>
                                       </p:cBhvr>
                                     </p:animEffect>
@@ -16562,7 +17188,7 @@
     </p:bg>
     <p:spTree>
       <p:nvGrpSpPr>
-        <p:cNvPr id="96" name="Shape 96"/>
+        <p:cNvPr id="98" name="Shape 98"/>
         <p:cNvGrpSpPr/>
         <p:nvPr/>
       </p:nvGrpSpPr>
@@ -16576,7 +17202,7 @@
       </p:grpSpPr>
       <p:sp>
         <p:nvSpPr>
-          <p:cNvPr id="97" name="Google Shape;97;p6"/>
+          <p:cNvPr id="99" name="Google Shape;99;p6"/>
           <p:cNvSpPr txBox="1"/>
           <p:nvPr/>
         </p:nvSpPr>
@@ -16639,7 +17265,7 @@
       </p:sp>
       <p:sp>
         <p:nvSpPr>
-          <p:cNvPr id="98" name="Google Shape;98;p6"/>
+          <p:cNvPr id="100" name="Google Shape;100;p6"/>
           <p:cNvSpPr txBox="1"/>
           <p:nvPr/>
         </p:nvSpPr>
@@ -16702,7 +17328,7 @@
       </p:sp>
       <p:sp>
         <p:nvSpPr>
-          <p:cNvPr id="99" name="Google Shape;99;p6"/>
+          <p:cNvPr id="101" name="Google Shape;101;p6"/>
           <p:cNvSpPr txBox="1"/>
           <p:nvPr/>
         </p:nvSpPr>
@@ -16765,7 +17391,7 @@
       </p:sp>
       <p:pic>
         <p:nvPicPr>
-          <p:cNvPr descr="preencoded.png" id="100" name="Google Shape;100;p6"/>
+          <p:cNvPr descr="preencoded.png" id="102" name="Google Shape;102;p6"/>
           <p:cNvPicPr preferRelativeResize="0"/>
           <p:nvPr/>
         </p:nvPicPr>
@@ -16799,7 +17425,7 @@
       </p:pic>
       <p:sp>
         <p:nvSpPr>
-          <p:cNvPr id="101" name="Google Shape;101;p6"/>
+          <p:cNvPr id="103" name="Google Shape;103;p6"/>
           <p:cNvSpPr txBox="1"/>
           <p:nvPr/>
         </p:nvSpPr>
@@ -16862,7 +17488,7 @@
       </p:sp>
       <p:pic>
         <p:nvPicPr>
-          <p:cNvPr id="102" name="Google Shape;102;p6" title="Screenshot 2026-10-03 at 15.42.41.png"/>
+          <p:cNvPr id="104" name="Google Shape;104;p6" title="Screenshot 2026-10-03 at 15.42.41.png"/>
           <p:cNvPicPr preferRelativeResize="0"/>
           <p:nvPr/>
         </p:nvPicPr>
@@ -16908,7 +17534,7 @@
     </p:bg>
     <p:spTree>
       <p:nvGrpSpPr>
-        <p:cNvPr id="107" name="Shape 107"/>
+        <p:cNvPr id="109" name="Shape 109"/>
         <p:cNvGrpSpPr/>
         <p:nvPr/>
       </p:nvGrpSpPr>
@@ -16922,7 +17548,7 @@
       </p:grpSpPr>
       <p:sp>
         <p:nvSpPr>
-          <p:cNvPr id="108" name="Google Shape;108;p7"/>
+          <p:cNvPr id="110" name="Google Shape;110;p7"/>
           <p:cNvSpPr/>
           <p:nvPr/>
         </p:nvSpPr>
@@ -16973,7 +17599,7 @@
       </p:sp>
       <p:sp>
         <p:nvSpPr>
-          <p:cNvPr id="109" name="Google Shape;109;p7"/>
+          <p:cNvPr id="111" name="Google Shape;111;p7"/>
           <p:cNvSpPr txBox="1"/>
           <p:nvPr/>
         </p:nvSpPr>
@@ -17036,7 +17662,7 @@
       </p:sp>
       <p:sp>
         <p:nvSpPr>
-          <p:cNvPr id="110" name="Google Shape;110;p7"/>
+          <p:cNvPr id="112" name="Google Shape;112;p7"/>
           <p:cNvSpPr/>
           <p:nvPr/>
         </p:nvSpPr>
@@ -17085,7 +17711,7 @@
       </p:sp>
       <p:pic>
         <p:nvPicPr>
-          <p:cNvPr descr="preencoded.png" id="111" name="Google Shape;111;p7"/>
+          <p:cNvPr descr="preencoded.png" id="113" name="Google Shape;113;p7"/>
           <p:cNvPicPr preferRelativeResize="0"/>
           <p:nvPr/>
         </p:nvPicPr>
@@ -17112,7 +17738,7 @@
       </p:pic>
       <p:sp>
         <p:nvSpPr>
-          <p:cNvPr id="112" name="Google Shape;112;p7"/>
+          <p:cNvPr id="114" name="Google Shape;114;p7"/>
           <p:cNvSpPr txBox="1"/>
           <p:nvPr/>
         </p:nvSpPr>
@@ -17175,7 +17801,7 @@
       </p:sp>
       <p:sp>
         <p:nvSpPr>
-          <p:cNvPr id="113" name="Google Shape;113;p7"/>
+          <p:cNvPr id="115" name="Google Shape;115;p7"/>
           <p:cNvSpPr txBox="1"/>
           <p:nvPr/>
         </p:nvSpPr>
@@ -17238,7 +17864,7 @@
       </p:sp>
       <p:sp>
         <p:nvSpPr>
-          <p:cNvPr id="114" name="Google Shape;114;p7"/>
+          <p:cNvPr id="116" name="Google Shape;116;p7"/>
           <p:cNvSpPr/>
           <p:nvPr/>
         </p:nvSpPr>
@@ -17287,7 +17913,7 @@
       </p:sp>
       <p:pic>
         <p:nvPicPr>
-          <p:cNvPr descr="preencoded.png" id="115" name="Google Shape;115;p7"/>
+          <p:cNvPr descr="preencoded.png" id="117" name="Google Shape;117;p7"/>
           <p:cNvPicPr preferRelativeResize="0"/>
           <p:nvPr/>
         </p:nvPicPr>
@@ -17314,7 +17940,7 @@
       </p:pic>
       <p:sp>
         <p:nvSpPr>
-          <p:cNvPr id="116" name="Google Shape;116;p7"/>
+          <p:cNvPr id="118" name="Google Shape;118;p7"/>
           <p:cNvSpPr txBox="1"/>
           <p:nvPr/>
         </p:nvSpPr>
@@ -17377,7 +18003,7 @@
       </p:sp>
       <p:sp>
         <p:nvSpPr>
-          <p:cNvPr id="117" name="Google Shape;117;p7"/>
+          <p:cNvPr id="119" name="Google Shape;119;p7"/>
           <p:cNvSpPr txBox="1"/>
           <p:nvPr/>
         </p:nvSpPr>
@@ -17440,7 +18066,7 @@
       </p:sp>
       <p:sp>
         <p:nvSpPr>
-          <p:cNvPr id="118" name="Google Shape;118;p7"/>
+          <p:cNvPr id="120" name="Google Shape;120;p7"/>
           <p:cNvSpPr/>
           <p:nvPr/>
         </p:nvSpPr>
@@ -17489,7 +18115,7 @@
       </p:sp>
       <p:pic>
         <p:nvPicPr>
-          <p:cNvPr descr="preencoded.png" id="119" name="Google Shape;119;p7"/>
+          <p:cNvPr descr="preencoded.png" id="121" name="Google Shape;121;p7"/>
           <p:cNvPicPr preferRelativeResize="0"/>
           <p:nvPr/>
         </p:nvPicPr>
@@ -17516,7 +18142,7 @@
       </p:pic>
       <p:sp>
         <p:nvSpPr>
-          <p:cNvPr id="120" name="Google Shape;120;p7"/>
+          <p:cNvPr id="122" name="Google Shape;122;p7"/>
           <p:cNvSpPr txBox="1"/>
           <p:nvPr/>
         </p:nvSpPr>
@@ -17579,7 +18205,7 @@
       </p:sp>
       <p:sp>
         <p:nvSpPr>
-          <p:cNvPr id="121" name="Google Shape;121;p7"/>
+          <p:cNvPr id="123" name="Google Shape;123;p7"/>
           <p:cNvSpPr txBox="1"/>
           <p:nvPr/>
         </p:nvSpPr>
@@ -17642,7 +18268,7 @@
       </p:sp>
       <p:sp>
         <p:nvSpPr>
-          <p:cNvPr id="122" name="Google Shape;122;p7"/>
+          <p:cNvPr id="124" name="Google Shape;124;p7"/>
           <p:cNvSpPr/>
           <p:nvPr/>
         </p:nvSpPr>
@@ -17691,7 +18317,7 @@
       </p:sp>
       <p:pic>
         <p:nvPicPr>
-          <p:cNvPr descr="preencoded.png" id="123" name="Google Shape;123;p7"/>
+          <p:cNvPr descr="preencoded.png" id="125" name="Google Shape;125;p7"/>
           <p:cNvPicPr preferRelativeResize="0"/>
           <p:nvPr/>
         </p:nvPicPr>
@@ -17718,7 +18344,7 @@
       </p:pic>
       <p:sp>
         <p:nvSpPr>
-          <p:cNvPr id="124" name="Google Shape;124;p7"/>
+          <p:cNvPr id="126" name="Google Shape;126;p7"/>
           <p:cNvSpPr txBox="1"/>
           <p:nvPr/>
         </p:nvSpPr>
@@ -17781,7 +18407,7 @@
       </p:sp>
       <p:sp>
         <p:nvSpPr>
-          <p:cNvPr id="125" name="Google Shape;125;p7"/>
+          <p:cNvPr id="127" name="Google Shape;127;p7"/>
           <p:cNvSpPr txBox="1"/>
           <p:nvPr/>
         </p:nvSpPr>
@@ -17844,7 +18470,7 @@
       </p:sp>
       <p:pic>
         <p:nvPicPr>
-          <p:cNvPr id="126" name="Google Shape;126;p7" title="Screenshot 2026-10-03 at 15.30.43.png"/>
+          <p:cNvPr id="128" name="Google Shape;128;p7" title="Screenshot 2026-10-03 at 15.30.43.png"/>
           <p:cNvPicPr preferRelativeResize="0"/>
           <p:nvPr/>
         </p:nvPicPr>

</xml_diff>